<commit_message>
docs(presentations): update Granite.build pitch deck with container/arrow/banner helpers
Co-Authored-By: Claude Opus 4.7 (1M context) <noreply@anthropic.com>
</commit_message>
<xml_diff>
--- a/docs/presentations/2026-04-28-openmythos-on-BlueVela.pptx
+++ b/docs/presentations/2026-04-28-openmythos-on-BlueVela.pptx
@@ -5,11 +5,11 @@
     <p:sldMasterId id="2147483648" r:id="rId1"/>
   </p:sldMasterIdLst>
   <p:sldIdLst>
-    <p:sldId id="256" r:id="rId7"/>
-    <p:sldId id="257" r:id="rId8"/>
-    <p:sldId id="258" r:id="rId9"/>
+    <p:sldId id="256" r:id="rId2"/>
+    <p:sldId id="257" r:id="rId3"/>
+    <p:sldId id="258" r:id="rId4"/>
   </p:sldIdLst>
-  <p:sldSz cx="12188952" cy="6858000" type="screen4x3"/>
+  <p:sldSz cx="12188825" cy="6858000"/>
   <p:notesSz cx="6858000" cy="9144000"/>
   <p:defaultTextStyle>
     <a:defPPr>
@@ -106,6 +106,22 @@
       </a:defRPr>
     </a:lvl9pPr>
   </p:defaultTextStyle>
+  <p:extLst>
+    <p:ext uri="{EFAFB233-063F-42B5-8137-9DF3F51BA10A}">
+      <p15:sldGuideLst xmlns:p15="http://schemas.microsoft.com/office/powerpoint/2012/main">
+        <p15:guide id="1" orient="horz" pos="2160">
+          <p15:clr>
+            <a:srgbClr val="A4A3A4"/>
+          </p15:clr>
+        </p15:guide>
+        <p15:guide id="2" pos="2880">
+          <p15:clr>
+            <a:srgbClr val="A4A3A4"/>
+          </p15:clr>
+        </p15:guide>
+      </p15:sldGuideLst>
+    </p:ext>
+  </p:extLst>
 </p:presentation>
 </file>
 
@@ -147,10 +163,9 @@
           <a:lstStyle/>
           <a:p>
             <a:r>
-              <a:rPr lang="en-US" smtClean="0"/>
+              <a:rPr lang="en-US"/>
               <a:t>Click to edit Master title style</a:t>
             </a:r>
-            <a:endParaRPr lang="en-US"/>
           </a:p>
         </p:txBody>
       </p:sp>
@@ -266,10 +281,9 @@
           </a:lstStyle>
           <a:p>
             <a:r>
-              <a:rPr lang="en-US" smtClean="0"/>
+              <a:rPr lang="en-US"/>
               <a:t>Click to edit Master subtitle style</a:t>
             </a:r>
-            <a:endParaRPr lang="en-US"/>
           </a:p>
         </p:txBody>
       </p:sp>
@@ -290,7 +304,7 @@
           <a:p>
             <a:fld id="{5BCAD085-E8A6-8845-BD4E-CB4CCA059FC4}" type="datetimeFigureOut">
               <a:rPr lang="en-US" smtClean="0"/>
-              <a:t>1/27/13</a:t>
+              <a:t>4/28/26</a:t>
             </a:fld>
             <a:endParaRPr lang="en-US"/>
           </a:p>
@@ -384,10 +398,9 @@
           <a:lstStyle/>
           <a:p>
             <a:r>
-              <a:rPr lang="en-US" smtClean="0"/>
+              <a:rPr lang="en-US"/>
               <a:t>Click to edit Master title style</a:t>
             </a:r>
-            <a:endParaRPr lang="en-US"/>
           </a:p>
         </p:txBody>
       </p:sp>
@@ -408,38 +421,37 @@
           <a:p>
             <a:pPr lvl="0"/>
             <a:r>
-              <a:rPr lang="en-US" smtClean="0"/>
+              <a:rPr lang="en-US"/>
               <a:t>Click to edit Master text styles</a:t>
             </a:r>
           </a:p>
           <a:p>
             <a:pPr lvl="1"/>
             <a:r>
-              <a:rPr lang="en-US" smtClean="0"/>
+              <a:rPr lang="en-US"/>
               <a:t>Second level</a:t>
             </a:r>
           </a:p>
           <a:p>
             <a:pPr lvl="2"/>
             <a:r>
-              <a:rPr lang="en-US" smtClean="0"/>
+              <a:rPr lang="en-US"/>
               <a:t>Third level</a:t>
             </a:r>
           </a:p>
           <a:p>
             <a:pPr lvl="3"/>
             <a:r>
-              <a:rPr lang="en-US" smtClean="0"/>
+              <a:rPr lang="en-US"/>
               <a:t>Fourth level</a:t>
             </a:r>
           </a:p>
           <a:p>
             <a:pPr lvl="4"/>
             <a:r>
-              <a:rPr lang="en-US" smtClean="0"/>
+              <a:rPr lang="en-US"/>
               <a:t>Fifth level</a:t>
             </a:r>
-            <a:endParaRPr lang="en-US"/>
           </a:p>
         </p:txBody>
       </p:sp>
@@ -460,7 +472,7 @@
           <a:p>
             <a:fld id="{5BCAD085-E8A6-8845-BD4E-CB4CCA059FC4}" type="datetimeFigureOut">
               <a:rPr lang="en-US" smtClean="0"/>
-              <a:t>1/27/13</a:t>
+              <a:t>4/28/26</a:t>
             </a:fld>
             <a:endParaRPr lang="en-US"/>
           </a:p>
@@ -559,10 +571,9 @@
           <a:lstStyle/>
           <a:p>
             <a:r>
-              <a:rPr lang="en-US" smtClean="0"/>
+              <a:rPr lang="en-US"/>
               <a:t>Click to edit Master title style</a:t>
             </a:r>
-            <a:endParaRPr lang="en-US"/>
           </a:p>
         </p:txBody>
       </p:sp>
@@ -588,38 +599,37 @@
           <a:p>
             <a:pPr lvl="0"/>
             <a:r>
-              <a:rPr lang="en-US" smtClean="0"/>
+              <a:rPr lang="en-US"/>
               <a:t>Click to edit Master text styles</a:t>
             </a:r>
           </a:p>
           <a:p>
             <a:pPr lvl="1"/>
             <a:r>
-              <a:rPr lang="en-US" smtClean="0"/>
+              <a:rPr lang="en-US"/>
               <a:t>Second level</a:t>
             </a:r>
           </a:p>
           <a:p>
             <a:pPr lvl="2"/>
             <a:r>
-              <a:rPr lang="en-US" smtClean="0"/>
+              <a:rPr lang="en-US"/>
               <a:t>Third level</a:t>
             </a:r>
           </a:p>
           <a:p>
             <a:pPr lvl="3"/>
             <a:r>
-              <a:rPr lang="en-US" smtClean="0"/>
+              <a:rPr lang="en-US"/>
               <a:t>Fourth level</a:t>
             </a:r>
           </a:p>
           <a:p>
             <a:pPr lvl="4"/>
             <a:r>
-              <a:rPr lang="en-US" smtClean="0"/>
+              <a:rPr lang="en-US"/>
               <a:t>Fifth level</a:t>
             </a:r>
-            <a:endParaRPr lang="en-US"/>
           </a:p>
         </p:txBody>
       </p:sp>
@@ -640,7 +650,7 @@
           <a:p>
             <a:fld id="{5BCAD085-E8A6-8845-BD4E-CB4CCA059FC4}" type="datetimeFigureOut">
               <a:rPr lang="en-US" smtClean="0"/>
-              <a:t>1/27/13</a:t>
+              <a:t>4/28/26</a:t>
             </a:fld>
             <a:endParaRPr lang="en-US"/>
           </a:p>
@@ -734,10 +744,9 @@
           <a:lstStyle/>
           <a:p>
             <a:r>
-              <a:rPr lang="en-US" smtClean="0"/>
+              <a:rPr lang="en-US"/>
               <a:t>Click to edit Master title style</a:t>
             </a:r>
-            <a:endParaRPr lang="en-US"/>
           </a:p>
         </p:txBody>
       </p:sp>
@@ -758,38 +767,37 @@
           <a:p>
             <a:pPr lvl="0"/>
             <a:r>
-              <a:rPr lang="en-US" smtClean="0"/>
+              <a:rPr lang="en-US"/>
               <a:t>Click to edit Master text styles</a:t>
             </a:r>
           </a:p>
           <a:p>
             <a:pPr lvl="1"/>
             <a:r>
-              <a:rPr lang="en-US" smtClean="0"/>
+              <a:rPr lang="en-US"/>
               <a:t>Second level</a:t>
             </a:r>
           </a:p>
           <a:p>
             <a:pPr lvl="2"/>
             <a:r>
-              <a:rPr lang="en-US" smtClean="0"/>
+              <a:rPr lang="en-US"/>
               <a:t>Third level</a:t>
             </a:r>
           </a:p>
           <a:p>
             <a:pPr lvl="3"/>
             <a:r>
-              <a:rPr lang="en-US" smtClean="0"/>
+              <a:rPr lang="en-US"/>
               <a:t>Fourth level</a:t>
             </a:r>
           </a:p>
           <a:p>
             <a:pPr lvl="4"/>
             <a:r>
-              <a:rPr lang="en-US" smtClean="0"/>
+              <a:rPr lang="en-US"/>
               <a:t>Fifth level</a:t>
             </a:r>
-            <a:endParaRPr lang="en-US"/>
           </a:p>
         </p:txBody>
       </p:sp>
@@ -810,7 +818,7 @@
           <a:p>
             <a:fld id="{5BCAD085-E8A6-8845-BD4E-CB4CCA059FC4}" type="datetimeFigureOut">
               <a:rPr lang="en-US" smtClean="0"/>
-              <a:t>1/27/13</a:t>
+              <a:t>4/28/26</a:t>
             </a:fld>
             <a:endParaRPr lang="en-US"/>
           </a:p>
@@ -913,10 +921,9 @@
           </a:lstStyle>
           <a:p>
             <a:r>
-              <a:rPr lang="en-US" smtClean="0"/>
+              <a:rPr lang="en-US"/>
               <a:t>Click to edit Master title style</a:t>
             </a:r>
-            <a:endParaRPr lang="en-US"/>
           </a:p>
         </p:txBody>
       </p:sp>
@@ -1033,7 +1040,7 @@
           <a:p>
             <a:pPr lvl="0"/>
             <a:r>
-              <a:rPr lang="en-US" smtClean="0"/>
+              <a:rPr lang="en-US"/>
               <a:t>Click to edit Master text styles</a:t>
             </a:r>
           </a:p>
@@ -1056,7 +1063,7 @@
           <a:p>
             <a:fld id="{5BCAD085-E8A6-8845-BD4E-CB4CCA059FC4}" type="datetimeFigureOut">
               <a:rPr lang="en-US" smtClean="0"/>
-              <a:t>1/27/13</a:t>
+              <a:t>4/28/26</a:t>
             </a:fld>
             <a:endParaRPr lang="en-US"/>
           </a:p>
@@ -1150,10 +1157,9 @@
           <a:lstStyle/>
           <a:p>
             <a:r>
-              <a:rPr lang="en-US" smtClean="0"/>
+              <a:rPr lang="en-US"/>
               <a:t>Click to edit Master title style</a:t>
             </a:r>
-            <a:endParaRPr lang="en-US"/>
           </a:p>
         </p:txBody>
       </p:sp>
@@ -1207,38 +1213,37 @@
           <a:p>
             <a:pPr lvl="0"/>
             <a:r>
-              <a:rPr lang="en-US" smtClean="0"/>
+              <a:rPr lang="en-US"/>
               <a:t>Click to edit Master text styles</a:t>
             </a:r>
           </a:p>
           <a:p>
             <a:pPr lvl="1"/>
             <a:r>
-              <a:rPr lang="en-US" smtClean="0"/>
+              <a:rPr lang="en-US"/>
               <a:t>Second level</a:t>
             </a:r>
           </a:p>
           <a:p>
             <a:pPr lvl="2"/>
             <a:r>
-              <a:rPr lang="en-US" smtClean="0"/>
+              <a:rPr lang="en-US"/>
               <a:t>Third level</a:t>
             </a:r>
           </a:p>
           <a:p>
             <a:pPr lvl="3"/>
             <a:r>
-              <a:rPr lang="en-US" smtClean="0"/>
+              <a:rPr lang="en-US"/>
               <a:t>Fourth level</a:t>
             </a:r>
           </a:p>
           <a:p>
             <a:pPr lvl="4"/>
             <a:r>
-              <a:rPr lang="en-US" smtClean="0"/>
+              <a:rPr lang="en-US"/>
               <a:t>Fifth level</a:t>
             </a:r>
-            <a:endParaRPr lang="en-US"/>
           </a:p>
         </p:txBody>
       </p:sp>
@@ -1292,38 +1297,37 @@
           <a:p>
             <a:pPr lvl="0"/>
             <a:r>
-              <a:rPr lang="en-US" smtClean="0"/>
+              <a:rPr lang="en-US"/>
               <a:t>Click to edit Master text styles</a:t>
             </a:r>
           </a:p>
           <a:p>
             <a:pPr lvl="1"/>
             <a:r>
-              <a:rPr lang="en-US" smtClean="0"/>
+              <a:rPr lang="en-US"/>
               <a:t>Second level</a:t>
             </a:r>
           </a:p>
           <a:p>
             <a:pPr lvl="2"/>
             <a:r>
-              <a:rPr lang="en-US" smtClean="0"/>
+              <a:rPr lang="en-US"/>
               <a:t>Third level</a:t>
             </a:r>
           </a:p>
           <a:p>
             <a:pPr lvl="3"/>
             <a:r>
-              <a:rPr lang="en-US" smtClean="0"/>
+              <a:rPr lang="en-US"/>
               <a:t>Fourth level</a:t>
             </a:r>
           </a:p>
           <a:p>
             <a:pPr lvl="4"/>
             <a:r>
-              <a:rPr lang="en-US" smtClean="0"/>
+              <a:rPr lang="en-US"/>
               <a:t>Fifth level</a:t>
             </a:r>
-            <a:endParaRPr lang="en-US"/>
           </a:p>
         </p:txBody>
       </p:sp>
@@ -1344,7 +1348,7 @@
           <a:p>
             <a:fld id="{5BCAD085-E8A6-8845-BD4E-CB4CCA059FC4}" type="datetimeFigureOut">
               <a:rPr lang="en-US" smtClean="0"/>
-              <a:t>1/27/13</a:t>
+              <a:t>4/28/26</a:t>
             </a:fld>
             <a:endParaRPr lang="en-US"/>
           </a:p>
@@ -1442,10 +1446,9 @@
           </a:lstStyle>
           <a:p>
             <a:r>
-              <a:rPr lang="en-US" smtClean="0"/>
+              <a:rPr lang="en-US"/>
               <a:t>Click to edit Master title style</a:t>
             </a:r>
-            <a:endParaRPr lang="en-US"/>
           </a:p>
         </p:txBody>
       </p:sp>
@@ -1508,7 +1511,7 @@
           <a:p>
             <a:pPr lvl="0"/>
             <a:r>
-              <a:rPr lang="en-US" smtClean="0"/>
+              <a:rPr lang="en-US"/>
               <a:t>Click to edit Master text styles</a:t>
             </a:r>
           </a:p>
@@ -1564,38 +1567,37 @@
           <a:p>
             <a:pPr lvl="0"/>
             <a:r>
-              <a:rPr lang="en-US" smtClean="0"/>
+              <a:rPr lang="en-US"/>
               <a:t>Click to edit Master text styles</a:t>
             </a:r>
           </a:p>
           <a:p>
             <a:pPr lvl="1"/>
             <a:r>
-              <a:rPr lang="en-US" smtClean="0"/>
+              <a:rPr lang="en-US"/>
               <a:t>Second level</a:t>
             </a:r>
           </a:p>
           <a:p>
             <a:pPr lvl="2"/>
             <a:r>
-              <a:rPr lang="en-US" smtClean="0"/>
+              <a:rPr lang="en-US"/>
               <a:t>Third level</a:t>
             </a:r>
           </a:p>
           <a:p>
             <a:pPr lvl="3"/>
             <a:r>
-              <a:rPr lang="en-US" smtClean="0"/>
+              <a:rPr lang="en-US"/>
               <a:t>Fourth level</a:t>
             </a:r>
           </a:p>
           <a:p>
             <a:pPr lvl="4"/>
             <a:r>
-              <a:rPr lang="en-US" smtClean="0"/>
+              <a:rPr lang="en-US"/>
               <a:t>Fifth level</a:t>
             </a:r>
-            <a:endParaRPr lang="en-US"/>
           </a:p>
         </p:txBody>
       </p:sp>
@@ -1658,7 +1660,7 @@
           <a:p>
             <a:pPr lvl="0"/>
             <a:r>
-              <a:rPr lang="en-US" smtClean="0"/>
+              <a:rPr lang="en-US"/>
               <a:t>Click to edit Master text styles</a:t>
             </a:r>
           </a:p>
@@ -1714,38 +1716,37 @@
           <a:p>
             <a:pPr lvl="0"/>
             <a:r>
-              <a:rPr lang="en-US" smtClean="0"/>
+              <a:rPr lang="en-US"/>
               <a:t>Click to edit Master text styles</a:t>
             </a:r>
           </a:p>
           <a:p>
             <a:pPr lvl="1"/>
             <a:r>
-              <a:rPr lang="en-US" smtClean="0"/>
+              <a:rPr lang="en-US"/>
               <a:t>Second level</a:t>
             </a:r>
           </a:p>
           <a:p>
             <a:pPr lvl="2"/>
             <a:r>
-              <a:rPr lang="en-US" smtClean="0"/>
+              <a:rPr lang="en-US"/>
               <a:t>Third level</a:t>
             </a:r>
           </a:p>
           <a:p>
             <a:pPr lvl="3"/>
             <a:r>
-              <a:rPr lang="en-US" smtClean="0"/>
+              <a:rPr lang="en-US"/>
               <a:t>Fourth level</a:t>
             </a:r>
           </a:p>
           <a:p>
             <a:pPr lvl="4"/>
             <a:r>
-              <a:rPr lang="en-US" smtClean="0"/>
+              <a:rPr lang="en-US"/>
               <a:t>Fifth level</a:t>
             </a:r>
-            <a:endParaRPr lang="en-US"/>
           </a:p>
         </p:txBody>
       </p:sp>
@@ -1766,7 +1767,7 @@
           <a:p>
             <a:fld id="{5BCAD085-E8A6-8845-BD4E-CB4CCA059FC4}" type="datetimeFigureOut">
               <a:rPr lang="en-US" smtClean="0"/>
-              <a:t>1/27/13</a:t>
+              <a:t>4/28/26</a:t>
             </a:fld>
             <a:endParaRPr lang="en-US"/>
           </a:p>
@@ -1860,10 +1861,9 @@
           <a:lstStyle/>
           <a:p>
             <a:r>
-              <a:rPr lang="en-US" smtClean="0"/>
+              <a:rPr lang="en-US"/>
               <a:t>Click to edit Master title style</a:t>
             </a:r>
-            <a:endParaRPr lang="en-US"/>
           </a:p>
         </p:txBody>
       </p:sp>
@@ -1884,7 +1884,7 @@
           <a:p>
             <a:fld id="{5BCAD085-E8A6-8845-BD4E-CB4CCA059FC4}" type="datetimeFigureOut">
               <a:rPr lang="en-US" smtClean="0"/>
-              <a:t>1/27/13</a:t>
+              <a:t>4/28/26</a:t>
             </a:fld>
             <a:endParaRPr lang="en-US"/>
           </a:p>
@@ -1979,7 +1979,7 @@
           <a:p>
             <a:fld id="{5BCAD085-E8A6-8845-BD4E-CB4CCA059FC4}" type="datetimeFigureOut">
               <a:rPr lang="en-US" smtClean="0"/>
-              <a:t>1/27/13</a:t>
+              <a:t>4/28/26</a:t>
             </a:fld>
             <a:endParaRPr lang="en-US"/>
           </a:p>
@@ -2082,10 +2082,9 @@
           </a:lstStyle>
           <a:p>
             <a:r>
-              <a:rPr lang="en-US" smtClean="0"/>
+              <a:rPr lang="en-US"/>
               <a:t>Click to edit Master title style</a:t>
             </a:r>
-            <a:endParaRPr lang="en-US"/>
           </a:p>
         </p:txBody>
       </p:sp>
@@ -2139,38 +2138,37 @@
           <a:p>
             <a:pPr lvl="0"/>
             <a:r>
-              <a:rPr lang="en-US" smtClean="0"/>
+              <a:rPr lang="en-US"/>
               <a:t>Click to edit Master text styles</a:t>
             </a:r>
           </a:p>
           <a:p>
             <a:pPr lvl="1"/>
             <a:r>
-              <a:rPr lang="en-US" smtClean="0"/>
+              <a:rPr lang="en-US"/>
               <a:t>Second level</a:t>
             </a:r>
           </a:p>
           <a:p>
             <a:pPr lvl="2"/>
             <a:r>
-              <a:rPr lang="en-US" smtClean="0"/>
+              <a:rPr lang="en-US"/>
               <a:t>Third level</a:t>
             </a:r>
           </a:p>
           <a:p>
             <a:pPr lvl="3"/>
             <a:r>
-              <a:rPr lang="en-US" smtClean="0"/>
+              <a:rPr lang="en-US"/>
               <a:t>Fourth level</a:t>
             </a:r>
           </a:p>
           <a:p>
             <a:pPr lvl="4"/>
             <a:r>
-              <a:rPr lang="en-US" smtClean="0"/>
+              <a:rPr lang="en-US"/>
               <a:t>Fifth level</a:t>
             </a:r>
-            <a:endParaRPr lang="en-US"/>
           </a:p>
         </p:txBody>
       </p:sp>
@@ -2233,7 +2231,7 @@
           <a:p>
             <a:pPr lvl="0"/>
             <a:r>
-              <a:rPr lang="en-US" smtClean="0"/>
+              <a:rPr lang="en-US"/>
               <a:t>Click to edit Master text styles</a:t>
             </a:r>
           </a:p>
@@ -2256,7 +2254,7 @@
           <a:p>
             <a:fld id="{5BCAD085-E8A6-8845-BD4E-CB4CCA059FC4}" type="datetimeFigureOut">
               <a:rPr lang="en-US" smtClean="0"/>
-              <a:t>1/27/13</a:t>
+              <a:t>4/28/26</a:t>
             </a:fld>
             <a:endParaRPr lang="en-US"/>
           </a:p>
@@ -2359,10 +2357,9 @@
           </a:lstStyle>
           <a:p>
             <a:r>
-              <a:rPr lang="en-US" smtClean="0"/>
+              <a:rPr lang="en-US"/>
               <a:t>Click to edit Master title style</a:t>
             </a:r>
-            <a:endParaRPr lang="en-US"/>
           </a:p>
         </p:txBody>
       </p:sp>
@@ -2486,7 +2483,7 @@
           <a:p>
             <a:pPr lvl="0"/>
             <a:r>
-              <a:rPr lang="en-US" smtClean="0"/>
+              <a:rPr lang="en-US"/>
               <a:t>Click to edit Master text styles</a:t>
             </a:r>
           </a:p>
@@ -2509,7 +2506,7 @@
           <a:p>
             <a:fld id="{5BCAD085-E8A6-8845-BD4E-CB4CCA059FC4}" type="datetimeFigureOut">
               <a:rPr lang="en-US" smtClean="0"/>
-              <a:t>1/27/13</a:t>
+              <a:t>4/28/26</a:t>
             </a:fld>
             <a:endParaRPr lang="en-US"/>
           </a:p>
@@ -2618,10 +2615,9 @@
           <a:lstStyle/>
           <a:p>
             <a:r>
-              <a:rPr lang="en-US" smtClean="0"/>
+              <a:rPr lang="en-US"/>
               <a:t>Click to edit Master title style</a:t>
             </a:r>
-            <a:endParaRPr lang="en-US"/>
           </a:p>
         </p:txBody>
       </p:sp>
@@ -2652,38 +2648,37 @@
           <a:p>
             <a:pPr lvl="0"/>
             <a:r>
-              <a:rPr lang="en-US" smtClean="0"/>
+              <a:rPr lang="en-US"/>
               <a:t>Click to edit Master text styles</a:t>
             </a:r>
           </a:p>
           <a:p>
             <a:pPr lvl="1"/>
             <a:r>
-              <a:rPr lang="en-US" smtClean="0"/>
+              <a:rPr lang="en-US"/>
               <a:t>Second level</a:t>
             </a:r>
           </a:p>
           <a:p>
             <a:pPr lvl="2"/>
             <a:r>
-              <a:rPr lang="en-US" smtClean="0"/>
+              <a:rPr lang="en-US"/>
               <a:t>Third level</a:t>
             </a:r>
           </a:p>
           <a:p>
             <a:pPr lvl="3"/>
             <a:r>
-              <a:rPr lang="en-US" smtClean="0"/>
+              <a:rPr lang="en-US"/>
               <a:t>Fourth level</a:t>
             </a:r>
           </a:p>
           <a:p>
             <a:pPr lvl="4"/>
             <a:r>
-              <a:rPr lang="en-US" smtClean="0"/>
+              <a:rPr lang="en-US"/>
               <a:t>Fifth level</a:t>
             </a:r>
-            <a:endParaRPr lang="en-US"/>
           </a:p>
         </p:txBody>
       </p:sp>
@@ -2722,7 +2717,7 @@
           <a:p>
             <a:fld id="{5BCAD085-E8A6-8845-BD4E-CB4CCA059FC4}" type="datetimeFigureOut">
               <a:rPr lang="en-US" smtClean="0"/>
-              <a:t>1/27/13</a:t>
+              <a:t>4/28/26</a:t>
             </a:fld>
             <a:endParaRPr lang="en-US"/>
           </a:p>
@@ -3081,7 +3076,7 @@
 </file>
 
 <file path=ppt/slides/slide1.xml><?xml version="1.0" encoding="utf-8"?>
-<p:sld xmlns:a="http://schemas.openxmlformats.org/drawingml/2006/main" xmlns:p="http://schemas.openxmlformats.org/presentationml/2006/main" xmlns:r="http://schemas.openxmlformats.org/officeDocument/2006/relationships">
+<p:sld xmlns:a="http://schemas.openxmlformats.org/drawingml/2006/main" xmlns:r="http://schemas.openxmlformats.org/officeDocument/2006/relationships" xmlns:p="http://schemas.openxmlformats.org/presentationml/2006/main">
   <p:cSld>
     <p:spTree>
       <p:nvGrpSpPr>
@@ -3089,7 +3084,14 @@
         <p:cNvGrpSpPr/>
         <p:nvPr/>
       </p:nvGrpSpPr>
-      <p:grpSpPr/>
+      <p:grpSpPr>
+        <a:xfrm>
+          <a:off x="0" y="0"/>
+          <a:ext cx="0" cy="0"/>
+          <a:chOff x="0" y="0"/>
+          <a:chExt cx="0" cy="0"/>
+        </a:xfrm>
+      </p:grpSpPr>
       <p:sp>
         <p:nvSpPr>
           <p:cNvPr id="2" name="TextBox 1"/>
@@ -3099,7 +3101,7 @@
         <p:spPr>
           <a:xfrm>
             <a:off x="457200" y="274320"/>
-            <a:ext cx="11247120" cy="914400"/>
+            <a:ext cx="11247120" cy="769441"/>
           </a:xfrm>
           <a:prstGeom prst="rect">
             <a:avLst/>
@@ -3113,22 +3115,70 @@
           <a:lstStyle/>
           <a:p>
             <a:r>
-              <a:rPr sz="3000" b="1">
+              <a:rPr lang="en-US" sz="3000" b="1" dirty="0">
                 <a:solidFill>
                   <a:srgbClr val="0B2A4A"/>
                 </a:solidFill>
               </a:rPr>
-              <a:t>OpenMythos on BlueVela: the cost of remote R&amp;D</a:t>
-            </a:r>
-          </a:p>
-          <a:p>
-            <a:r>
-              <a:rPr sz="1400" i="1">
+              <a:t>Use Case: </a:t>
+            </a:r>
+            <a:r>
+              <a:rPr sz="3000" b="1" dirty="0" err="1">
+                <a:solidFill>
+                  <a:srgbClr val="0B2A4A"/>
+                </a:solidFill>
+              </a:rPr>
+              <a:t>OpenMythos</a:t>
+            </a:r>
+            <a:r>
+              <a:rPr sz="3000" b="1" dirty="0">
+                <a:solidFill>
+                  <a:srgbClr val="0B2A4A"/>
+                </a:solidFill>
+              </a:rPr>
+              <a:t> on </a:t>
+            </a:r>
+            <a:r>
+              <a:rPr sz="3000" b="1" dirty="0" err="1">
+                <a:solidFill>
+                  <a:srgbClr val="0B2A4A"/>
+                </a:solidFill>
+              </a:rPr>
+              <a:t>BlueVela</a:t>
+            </a:r>
+            <a:r>
+              <a:rPr sz="3000" b="1" dirty="0">
+                <a:solidFill>
+                  <a:srgbClr val="0B2A4A"/>
+                </a:solidFill>
+              </a:rPr>
+              <a:t>: the cost of remote R&amp;D</a:t>
+            </a:r>
+          </a:p>
+          <a:p>
+            <a:r>
+              <a:rPr sz="1400" i="1" dirty="0">
                 <a:solidFill>
                   <a:srgbClr val="555555"/>
                 </a:solidFill>
               </a:rPr>
-              <a:t>Recurrent-Depth Transformer bringup — Apr 22–24, 2026</a:t>
+              <a:t>Recurrent-Depth Transformer </a:t>
+            </a:r>
+            <a:r>
+              <a:rPr sz="1400" i="1" dirty="0" err="1">
+                <a:solidFill>
+                  <a:srgbClr val="555555"/>
+                </a:solidFill>
+              </a:rPr>
+              <a:t>bringup</a:t>
+            </a:r>
+            <a:r>
+              <a:rPr sz="1400" i="1" dirty="0">
+                <a:solidFill>
+                  <a:srgbClr val="555555"/>
+                </a:solidFill>
+              </a:rPr>
+              <a:t> — Apr 22–24, 2026</a:t>
             </a:r>
           </a:p>
         </p:txBody>
@@ -3155,7 +3205,6 @@
           </a:bodyPr>
           <a:lstStyle/>
           <a:p>
-            <a:pPr/>
             <a:r>
               <a:rPr sz="1300">
                 <a:solidFill>
@@ -3166,7 +3215,6 @@
             </a:r>
           </a:p>
           <a:p>
-            <a:pPr/>
             <a:r>
               <a:rPr sz="1300">
                 <a:solidFill>
@@ -3249,18 +3297,31 @@
           </a:fontRef>
         </p:style>
         <p:txBody>
-          <a:bodyPr rtlCol="0" anchor="ctr" lIns="45720" rIns="45720"/>
+          <a:bodyPr lIns="45720" rIns="45720" rtlCol="0" anchor="ctr"/>
           <a:lstStyle/>
           <a:p>
             <a:pPr algn="l"/>
             <a:r>
-              <a:rPr sz="1100" b="1">
+              <a:rPr sz="1100" b="1" dirty="0">
                 <a:solidFill>
                   <a:srgbClr val="0B2A4A"/>
                 </a:solidFill>
               </a:rPr>
               <a:t>edit locally</a:t>
             </a:r>
+            <a:r>
+              <a:rPr lang="en-US" sz="1100" b="1" dirty="0">
+                <a:solidFill>
+                  <a:srgbClr val="0B2A4A"/>
+                </a:solidFill>
+              </a:rPr>
+              <a:t> (laptop)</a:t>
+            </a:r>
+            <a:endParaRPr sz="1100" b="1" dirty="0">
+              <a:solidFill>
+                <a:srgbClr val="0B2A4A"/>
+              </a:solidFill>
+            </a:endParaRPr>
           </a:p>
         </p:txBody>
       </p:sp>
@@ -3302,7 +3363,7 @@
           </a:fontRef>
         </p:style>
         <p:txBody>
-          <a:bodyPr rtlCol="0" anchor="ctr" lIns="45720" rIns="45720"/>
+          <a:bodyPr lIns="45720" rIns="45720" rtlCol="0" anchor="ctr"/>
           <a:lstStyle/>
           <a:p>
             <a:pPr algn="l"/>
@@ -3355,7 +3416,7 @@
           </a:fontRef>
         </p:style>
         <p:txBody>
-          <a:bodyPr rtlCol="0" anchor="ctr" lIns="45720" rIns="45720"/>
+          <a:bodyPr lIns="45720" rIns="45720" rtlCol="0" anchor="ctr"/>
           <a:lstStyle/>
           <a:p>
             <a:pPr algn="l"/>
@@ -3408,7 +3469,7 @@
           </a:fontRef>
         </p:style>
         <p:txBody>
-          <a:bodyPr rtlCol="0" anchor="ctr" lIns="45720" rIns="45720"/>
+          <a:bodyPr lIns="45720" rIns="45720" rtlCol="0" anchor="ctr"/>
           <a:lstStyle/>
           <a:p>
             <a:pPr algn="l"/>
@@ -3461,7 +3522,7 @@
           </a:fontRef>
         </p:style>
         <p:txBody>
-          <a:bodyPr rtlCol="0" anchor="ctr" lIns="45720" rIns="45720"/>
+          <a:bodyPr lIns="45720" rIns="45720" rtlCol="0" anchor="ctr"/>
           <a:lstStyle/>
           <a:p>
             <a:pPr algn="l"/>
@@ -3514,7 +3575,7 @@
           </a:fontRef>
         </p:style>
         <p:txBody>
-          <a:bodyPr rtlCol="0" anchor="ctr" lIns="45720" rIns="45720"/>
+          <a:bodyPr lIns="45720" rIns="45720" rtlCol="0" anchor="ctr"/>
           <a:lstStyle/>
           <a:p>
             <a:pPr algn="l"/>
@@ -3567,7 +3628,7 @@
           </a:fontRef>
         </p:style>
         <p:txBody>
-          <a:bodyPr rtlCol="0" anchor="ctr" lIns="45720" rIns="45720"/>
+          <a:bodyPr lIns="45720" rIns="45720" rtlCol="0" anchor="ctr"/>
           <a:lstStyle/>
           <a:p>
             <a:pPr algn="l"/>
@@ -3591,7 +3652,7 @@
         <p:spPr>
           <a:xfrm>
             <a:off x="457200" y="3611880"/>
-            <a:ext cx="5669280" cy="2560320"/>
+            <a:ext cx="5669280" cy="1631216"/>
           </a:xfrm>
           <a:prstGeom prst="rect">
             <a:avLst/>
@@ -3605,7 +3666,7 @@
           <a:lstStyle/>
           <a:p>
             <a:r>
-              <a:rPr sz="1600" b="1">
+              <a:rPr sz="1600" b="1" dirty="0">
                 <a:solidFill>
                   <a:srgbClr val="C93C20"/>
                 </a:solidFill>
@@ -3614,80 +3675,145 @@
             </a:r>
           </a:p>
           <a:p>
-            <a:pPr/>
+            <a:r>
+              <a:rPr sz="1200" dirty="0">
+                <a:solidFill>
+                  <a:srgbClr val="111111"/>
+                </a:solidFill>
+              </a:rPr>
+              <a:t>• ~475 SSH connections in 3 days across 4 Claude Code sessions</a:t>
+            </a:r>
+          </a:p>
+          <a:p>
+            <a:r>
+              <a:rPr sz="1200" dirty="0">
+                <a:solidFill>
+                  <a:srgbClr val="111111"/>
+                </a:solidFill>
+              </a:rPr>
+              <a:t>• ~214 direct commands + ~260 monitor-loop polls</a:t>
+            </a:r>
+          </a:p>
+          <a:p>
+            <a:r>
+              <a:rPr sz="1200" dirty="0">
+                <a:solidFill>
+                  <a:srgbClr val="111111"/>
+                </a:solidFill>
+              </a:rPr>
+              <a:t>• 20 LSF jobs submitted; most failed iteratively:</a:t>
+            </a:r>
+          </a:p>
+          <a:p>
+            <a:r>
+              <a:rPr sz="1200" dirty="0">
+                <a:solidFill>
+                  <a:srgbClr val="111111"/>
+                </a:solidFill>
+              </a:rPr>
+              <a:t>• 5 rounds of FSDP mixed-precision </a:t>
+            </a:r>
+            <a:r>
+              <a:rPr sz="1200" dirty="0" err="1">
+                <a:solidFill>
+                  <a:srgbClr val="111111"/>
+                </a:solidFill>
+              </a:rPr>
+              <a:t>dtype</a:t>
+            </a:r>
+            <a:r>
+              <a:rPr sz="1200" dirty="0">
+                <a:solidFill>
+                  <a:srgbClr val="111111"/>
+                </a:solidFill>
+              </a:rPr>
+              <a:t> fixes</a:t>
+            </a:r>
+          </a:p>
+          <a:p>
+            <a:r>
+              <a:rPr sz="1200" dirty="0">
+                <a:solidFill>
+                  <a:srgbClr val="111111"/>
+                </a:solidFill>
+              </a:rPr>
+              <a:t>• OOM at </a:t>
+            </a:r>
+            <a:r>
+              <a:rPr sz="1200" dirty="0" err="1">
+                <a:solidFill>
+                  <a:srgbClr val="111111"/>
+                </a:solidFill>
+              </a:rPr>
+              <a:t>micro_batch</a:t>
+            </a:r>
+            <a:r>
+              <a:rPr sz="1200" dirty="0">
+                <a:solidFill>
+                  <a:srgbClr val="111111"/>
+                </a:solidFill>
+              </a:rPr>
+              <a:t>=4, 2 → settled on 1</a:t>
+            </a:r>
+          </a:p>
+          <a:p>
             <a:r>
               <a:rPr sz="1200">
                 <a:solidFill>
                   <a:srgbClr val="111111"/>
                 </a:solidFill>
               </a:rPr>
-              <a:t>• ~475 SSH connections in 3 days across 4 Claude Code sessions</a:t>
-            </a:r>
-          </a:p>
-          <a:p>
-            <a:pPr/>
-            <a:r>
-              <a:rPr sz="1200">
+              <a:t>• NCCL </a:t>
+            </a:r>
+            <a:r>
+              <a:rPr sz="1200" dirty="0">
                 <a:solidFill>
                   <a:srgbClr val="111111"/>
                 </a:solidFill>
               </a:rPr>
-              <a:t>•   ~214 direct commands + ~260 monitor-loop polls</a:t>
-            </a:r>
-          </a:p>
-          <a:p>
-            <a:pPr/>
-            <a:r>
-              <a:rPr sz="1200">
+              <a:t>timeout, ACT deadlock, </a:t>
+            </a:r>
+            <a:r>
+              <a:rPr sz="1200" dirty="0" err="1">
                 <a:solidFill>
                   <a:srgbClr val="111111"/>
                 </a:solidFill>
               </a:rPr>
-              <a:t>• 20 LSF jobs submitted; most failed iteratively:</a:t>
-            </a:r>
-          </a:p>
-          <a:p>
-            <a:pPr/>
-            <a:r>
-              <a:rPr sz="1200">
+              <a:t>ClearML</a:t>
+            </a:r>
+            <a:r>
+              <a:rPr sz="1200" dirty="0">
                 <a:solidFill>
                   <a:srgbClr val="111111"/>
                 </a:solidFill>
               </a:rPr>
-              <a:t>•   5 rounds of FSDP mixed-precision dtype fixes</a:t>
-            </a:r>
-          </a:p>
-          <a:p>
-            <a:pPr/>
-            <a:r>
-              <a:rPr sz="1200">
+              <a:t> 10-min hang</a:t>
+            </a:r>
+          </a:p>
+          <a:p>
+            <a:r>
+              <a:rPr sz="1200" dirty="0">
                 <a:solidFill>
                   <a:srgbClr val="111111"/>
                 </a:solidFill>
               </a:rPr>
-              <a:t>•   OOM at micro_batch=4, 2 → settled on 1</a:t>
-            </a:r>
-          </a:p>
-          <a:p>
-            <a:pPr/>
-            <a:r>
-              <a:rPr sz="1200">
+              <a:t>• Heaviest session: 113 SSH in ~12 </a:t>
+            </a:r>
+            <a:r>
+              <a:rPr sz="1200" dirty="0" err="1">
                 <a:solidFill>
                   <a:srgbClr val="111111"/>
                 </a:solidFill>
               </a:rPr>
-              <a:t>•   NCCL timeout, ACT deadlock, ClearML 10-min hang</a:t>
-            </a:r>
-          </a:p>
-          <a:p>
-            <a:pPr/>
-            <a:r>
-              <a:rPr sz="1200">
+              <a:t>hrs</a:t>
+            </a:r>
+            <a:r>
+              <a:rPr sz="1200" dirty="0">
                 <a:solidFill>
                   <a:srgbClr val="111111"/>
                 </a:solidFill>
               </a:rPr>
-              <a:t>• Heaviest session: 113 SSH in ~12 hrs — ~1 SSH every 4.5 min</a:t>
+              <a:t> — ~1 SSH every 4.5 min</a:t>
             </a:r>
           </a:p>
         </p:txBody>
@@ -3701,7 +3827,7 @@
         <p:spPr>
           <a:xfrm>
             <a:off x="6355080" y="3611880"/>
-            <a:ext cx="5486400" cy="2560320"/>
+            <a:ext cx="5486400" cy="1446550"/>
           </a:xfrm>
           <a:prstGeom prst="rect">
             <a:avLst/>
@@ -3715,7 +3841,7 @@
           <a:lstStyle/>
           <a:p>
             <a:r>
-              <a:rPr sz="1600" b="1">
+              <a:rPr sz="1600" b="1" dirty="0">
                 <a:solidFill>
                   <a:srgbClr val="C93C20"/>
                 </a:solidFill>
@@ -3724,9 +3850,8 @@
             </a:r>
           </a:p>
           <a:p>
-            <a:pPr/>
-            <a:r>
-              <a:rPr sz="1200">
+            <a:r>
+              <a:rPr sz="1200" dirty="0">
                 <a:solidFill>
                   <a:srgbClr val="111111"/>
                 </a:solidFill>
@@ -3735,47 +3860,135 @@
             </a:r>
           </a:p>
           <a:p>
-            <a:pPr/>
-            <a:r>
-              <a:rPr sz="1200">
+            <a:r>
+              <a:rPr sz="1200" dirty="0">
                 <a:solidFill>
                   <a:srgbClr val="111111"/>
                 </a:solidFill>
               </a:rPr>
-              <a:t>•   5–10 SSH round-trips per bug to diagnose + verify the fix</a:t>
-            </a:r>
-          </a:p>
-          <a:p>
-            <a:pPr/>
-            <a:r>
-              <a:rPr sz="1200">
+              <a:t>• 5–10 SSH round-trips per bug to diagnose + verify the fix</a:t>
+            </a:r>
+          </a:p>
+          <a:p>
+            <a:r>
+              <a:rPr sz="1200" dirty="0">
                 <a:solidFill>
                   <a:srgbClr val="111111"/>
                 </a:solidFill>
               </a:rPr>
-              <a:t>• Remote cluster has no interactive compute-node access</a:t>
-            </a:r>
-          </a:p>
-          <a:p>
-            <a:pPr/>
-            <a:r>
-              <a:rPr sz="1200">
+              <a:t>• </a:t>
+            </a:r>
+            <a:r>
+              <a:rPr lang="en-US" sz="1200" dirty="0">
                 <a:solidFill>
                   <a:srgbClr val="111111"/>
                 </a:solidFill>
               </a:rPr>
-              <a:t>• Monitor loops poll bjobs/bpeek every 10–15 s just to detect state change</a:t>
-            </a:r>
-          </a:p>
-          <a:p>
-            <a:pPr/>
-            <a:r>
-              <a:rPr sz="1200">
+              <a:t>Interactive compute-nodes in </a:t>
+            </a:r>
+            <a:r>
+              <a:rPr lang="en-US" sz="1200" dirty="0" err="1">
                 <a:solidFill>
                   <a:srgbClr val="111111"/>
                 </a:solidFill>
               </a:rPr>
+              <a:t>BlueVela</a:t>
+            </a:r>
+            <a:r>
+              <a:rPr lang="en-US" sz="1200" dirty="0">
+                <a:solidFill>
+                  <a:srgbClr val="111111"/>
+                </a:solidFill>
+              </a:rPr>
+              <a:t> are to be used scarcely </a:t>
+            </a:r>
+            <a:endParaRPr sz="1200" dirty="0">
+              <a:solidFill>
+                <a:srgbClr val="111111"/>
+              </a:solidFill>
+            </a:endParaRPr>
+          </a:p>
+          <a:p>
+            <a:r>
+              <a:rPr sz="1200" dirty="0">
+                <a:solidFill>
+                  <a:srgbClr val="111111"/>
+                </a:solidFill>
+              </a:rPr>
+              <a:t>• Monitor loops poll </a:t>
+            </a:r>
+            <a:r>
+              <a:rPr sz="1200" dirty="0" err="1">
+                <a:solidFill>
+                  <a:srgbClr val="111111"/>
+                </a:solidFill>
+              </a:rPr>
+              <a:t>bjobs</a:t>
+            </a:r>
+            <a:r>
+              <a:rPr sz="1200" dirty="0">
+                <a:solidFill>
+                  <a:srgbClr val="111111"/>
+                </a:solidFill>
+              </a:rPr>
+              <a:t>/</a:t>
+            </a:r>
+            <a:r>
+              <a:rPr sz="1200" dirty="0" err="1">
+                <a:solidFill>
+                  <a:srgbClr val="111111"/>
+                </a:solidFill>
+              </a:rPr>
+              <a:t>bpeek</a:t>
+            </a:r>
+            <a:r>
+              <a:rPr sz="1200" dirty="0">
+                <a:solidFill>
+                  <a:srgbClr val="111111"/>
+                </a:solidFill>
+              </a:rPr>
+              <a:t> every 10–15 s just to detect state change</a:t>
+            </a:r>
+          </a:p>
+          <a:p>
+            <a:r>
+              <a:rPr sz="1200" dirty="0">
+                <a:solidFill>
+                  <a:srgbClr val="111111"/>
+                </a:solidFill>
+              </a:rPr>
               <a:t>• Engineer time is dominated by plumbing — not modeling</a:t>
+            </a:r>
+            <a:endParaRPr lang="en-US" sz="1200" dirty="0">
+              <a:solidFill>
+                <a:srgbClr val="111111"/>
+              </a:solidFill>
+            </a:endParaRPr>
+          </a:p>
+          <a:p>
+            <a:r>
+              <a:rPr lang="en-US" sz="1200" dirty="0">
+                <a:solidFill>
+                  <a:srgbClr val="111111"/>
+                </a:solidFill>
+              </a:rPr>
+              <a:t>• Does coding agent </a:t>
+            </a:r>
+            <a:r>
+              <a:rPr lang="en-US" sz="1200" i="1" dirty="0">
+                <a:solidFill>
+                  <a:srgbClr val="111111"/>
+                </a:solidFill>
+              </a:rPr>
+              <a:t>always </a:t>
+            </a:r>
+            <a:r>
+              <a:rPr lang="en-US" sz="1200" dirty="0">
+                <a:solidFill>
+                  <a:srgbClr val="111111"/>
+                </a:solidFill>
+              </a:rPr>
+              <a:t>follow instructions when you hand-over the SSH keys? </a:t>
             </a:r>
           </a:p>
         </p:txBody>
@@ -3816,7 +4029,7 @@
           </a:fontRef>
         </p:style>
         <p:txBody>
-          <a:bodyPr rtlCol="0" anchor="ctr" lIns="274320" rIns="274320"/>
+          <a:bodyPr lIns="274320" rIns="274320" rtlCol="0" anchor="ctr"/>
           <a:lstStyle/>
           <a:p>
             <a:pPr algn="l"/>
@@ -3840,7 +4053,7 @@
 </file>
 
 <file path=ppt/slides/slide2.xml><?xml version="1.0" encoding="utf-8"?>
-<p:sld xmlns:a="http://schemas.openxmlformats.org/drawingml/2006/main" xmlns:p="http://schemas.openxmlformats.org/presentationml/2006/main" xmlns:r="http://schemas.openxmlformats.org/officeDocument/2006/relationships">
+<p:sld xmlns:a="http://schemas.openxmlformats.org/drawingml/2006/main" xmlns:r="http://schemas.openxmlformats.org/officeDocument/2006/relationships" xmlns:p="http://schemas.openxmlformats.org/presentationml/2006/main">
   <p:cSld>
     <p:spTree>
       <p:nvGrpSpPr>
@@ -3848,7 +4061,14 @@
         <p:cNvGrpSpPr/>
         <p:nvPr/>
       </p:nvGrpSpPr>
-      <p:grpSpPr/>
+      <p:grpSpPr>
+        <a:xfrm>
+          <a:off x="0" y="0"/>
+          <a:ext cx="0" cy="0"/>
+          <a:chOff x="0" y="0"/>
+          <a:chExt cx="0" cy="0"/>
+        </a:xfrm>
+      </p:grpSpPr>
       <p:sp>
         <p:nvSpPr>
           <p:cNvPr id="2" name="TextBox 1"/>
@@ -3894,199 +4114,25 @@
       </p:sp>
       <p:sp>
         <p:nvSpPr>
-          <p:cNvPr id="3" name="TextBox 2"/>
-          <p:cNvSpPr txBox="1"/>
+          <p:cNvPr id="3" name="Rounded Rectangle 2"/>
+          <p:cNvSpPr/>
           <p:nvPr/>
         </p:nvSpPr>
         <p:spPr>
           <a:xfrm>
-            <a:off x="457200" y="1325880"/>
-            <a:ext cx="5669280" cy="4754880"/>
-          </a:xfrm>
-          <a:prstGeom prst="rect">
+            <a:off x="365760" y="1325880"/>
+            <a:ext cx="3840480" cy="2331720"/>
+          </a:xfrm>
+          <a:prstGeom prst="roundRect">
             <a:avLst/>
           </a:prstGeom>
-          <a:noFill/>
-        </p:spPr>
-        <p:txBody>
-          <a:bodyPr wrap="square">
-            <a:spAutoFit/>
-          </a:bodyPr>
-          <a:lstStyle/>
-          <a:p>
-            <a:r>
-              <a:rPr sz="1600" b="1">
-                <a:solidFill>
-                  <a:srgbClr val="0B2A4A"/>
-                </a:solidFill>
-              </a:rPr>
-              <a:t>a) Safe, persistent agent sandbox with a GPU</a:t>
-            </a:r>
-          </a:p>
-          <a:p>
-            <a:pPr/>
-            <a:r>
-              <a:rPr sz="1300">
-                <a:solidFill>
-                  <a:srgbClr val="111111"/>
-                </a:solidFill>
-              </a:rPr>
-              <a:t>• Persistent container (OpenShell) with Claude Code, Git, Docker/Podman, Python</a:t>
-            </a:r>
-          </a:p>
-          <a:p>
-            <a:pPr/>
-            <a:r>
-              <a:rPr sz="1300">
-                <a:solidFill>
-                  <a:srgbClr val="111111"/>
-                </a:solidFill>
-              </a:rPr>
-              <a:t>• Optional local GPU for prototyping before scaling out</a:t>
-            </a:r>
-          </a:p>
-          <a:p>
-            <a:pPr/>
-            <a:r>
-              <a:rPr sz="1300">
-                <a:solidFill>
-                  <a:srgbClr val="111111"/>
-                </a:solidFill>
-              </a:rPr>
-              <a:t>• Persists across sessions — decoupled from the laptop; no laptop ↔ cluster tunnel</a:t>
-            </a:r>
-          </a:p>
-          <a:p>
-            <a:pPr/>
-            <a:r>
-              <a:rPr sz="1300">
-                <a:solidFill>
-                  <a:srgbClr val="111111"/>
-                </a:solidFill>
-              </a:rPr>
-              <a:t>• Safe execution: preflight validation, space-scoped credentials and artifacts</a:t>
-            </a:r>
-          </a:p>
-          <a:p>
-            <a:pPr/>
-            <a:r>
-              <a:rPr sz="1300">
-                <a:solidFill>
-                  <a:srgbClr val="111111"/>
-                </a:solidFill>
-              </a:rPr>
-              <a:t>• Agent Guide tells Claude Code which MCP tools exist and when to use each</a:t>
-            </a:r>
-          </a:p>
-        </p:txBody>
-      </p:sp>
-      <p:sp>
-        <p:nvSpPr>
-          <p:cNvPr id="4" name="TextBox 3"/>
-          <p:cNvSpPr txBox="1"/>
-          <p:nvPr/>
-        </p:nvSpPr>
-        <p:spPr>
-          <a:xfrm>
-            <a:off x="6355080" y="1325880"/>
-            <a:ext cx="5486400" cy="4754880"/>
-          </a:xfrm>
-          <a:prstGeom prst="rect">
-            <a:avLst/>
-          </a:prstGeom>
-          <a:noFill/>
-        </p:spPr>
-        <p:txBody>
-          <a:bodyPr wrap="square">
-            <a:spAutoFit/>
-          </a:bodyPr>
-          <a:lstStyle/>
-          <a:p>
-            <a:r>
-              <a:rPr sz="1600" b="1">
-                <a:solidFill>
-                  <a:srgbClr val="0B2A4A"/>
-                </a:solidFill>
-              </a:rPr>
-              <a:t>b) Granite.build as the scale mediation layer</a:t>
-            </a:r>
-          </a:p>
-          <a:p>
-            <a:pPr/>
-            <a:r>
-              <a:rPr sz="1300">
-                <a:solidFill>
-                  <a:srgbClr val="111111"/>
-                </a:solidFill>
-              </a:rPr>
-              <a:t>• Control-plane-only: build specs reference commit SHAs + content-addressed images — no data moves through the agent</a:t>
-            </a:r>
-          </a:p>
-          <a:p>
-            <a:pPr/>
-            <a:r>
-              <a:rPr sz="1300">
-                <a:solidFill>
-                  <a:srgbClr val="111111"/>
-                </a:solidFill>
-              </a:rPr>
-              <a:t>• Deterministic, reproducible runs with artifact lineage and provenance</a:t>
-            </a:r>
-          </a:p>
-          <a:p>
-            <a:pPr/>
-            <a:r>
-              <a:rPr sz="1300">
-                <a:solidFill>
-                  <a:srgbClr val="111111"/>
-                </a:solidFill>
-              </a:rPr>
-              <a:t>• Compute backends (Bash / Docker / RunPod; later K8s/LSF) fetch code, images, and artifacts themselves</a:t>
-            </a:r>
-          </a:p>
-          <a:p>
-            <a:pPr/>
-            <a:r>
-              <a:rPr sz="1300">
-                <a:solidFill>
-                  <a:srgbClr val="111111"/>
-                </a:solidFill>
-              </a:rPr>
-              <a:t>• 10 MCP tools let the agent discover steps, environments, quotas, and submit jobs directly</a:t>
-            </a:r>
-          </a:p>
-          <a:p>
-            <a:pPr/>
-            <a:r>
-              <a:rPr sz="1300">
-                <a:solidFill>
-                  <a:srgbClr val="111111"/>
-                </a:solidFill>
-              </a:rPr>
-              <a:t>• Preflight validation blocks bad specs before a GPU is ever allocated</a:t>
-            </a:r>
-          </a:p>
-        </p:txBody>
-      </p:sp>
-      <p:sp>
-        <p:nvSpPr>
-          <p:cNvPr id="5" name="Rectangle 4"/>
-          <p:cNvSpPr/>
-          <p:nvPr/>
-        </p:nvSpPr>
-        <p:spPr>
-          <a:xfrm>
-            <a:off x="0" y="6309360"/>
-            <a:ext cx="12188952" cy="548640"/>
-          </a:xfrm>
-          <a:prstGeom prst="rect">
-            <a:avLst/>
-          </a:prstGeom>
-          <a:solidFill>
-            <a:srgbClr val="0B2A4A"/>
-          </a:solidFill>
-          <a:ln>
-            <a:noFill/>
+          <a:solidFill>
+            <a:srgbClr val="FAFAFA"/>
+          </a:solidFill>
+          <a:ln w="19050">
+            <a:solidFill>
+              <a:srgbClr val="0B2A4A"/>
+            </a:solidFill>
           </a:ln>
         </p:spPr>
         <p:style>
@@ -4104,7 +4150,1086 @@
           </a:fontRef>
         </p:style>
         <p:txBody>
-          <a:bodyPr rtlCol="0" anchor="ctr" lIns="274320" rIns="274320"/>
+          <a:bodyPr rtlCol="0" anchor="ctr"/>
+          <a:lstStyle/>
+          <a:p>
+            <a:endParaRPr/>
+          </a:p>
+        </p:txBody>
+      </p:sp>
+      <p:sp>
+        <p:nvSpPr>
+          <p:cNvPr id="4" name="Rectangle 3"/>
+          <p:cNvSpPr/>
+          <p:nvPr/>
+        </p:nvSpPr>
+        <p:spPr>
+          <a:xfrm>
+            <a:off x="365760" y="1325880"/>
+            <a:ext cx="3840480" cy="365760"/>
+          </a:xfrm>
+          <a:prstGeom prst="rect">
+            <a:avLst/>
+          </a:prstGeom>
+          <a:solidFill>
+            <a:srgbClr val="0B2A4A"/>
+          </a:solidFill>
+          <a:ln>
+            <a:noFill/>
+          </a:ln>
+        </p:spPr>
+        <p:style>
+          <a:lnRef idx="1">
+            <a:schemeClr val="accent1"/>
+          </a:lnRef>
+          <a:fillRef idx="3">
+            <a:schemeClr val="accent1"/>
+          </a:fillRef>
+          <a:effectRef idx="2">
+            <a:schemeClr val="accent1"/>
+          </a:effectRef>
+          <a:fontRef idx="minor">
+            <a:schemeClr val="lt1"/>
+          </a:fontRef>
+        </p:style>
+        <p:txBody>
+          <a:bodyPr tIns="27432" bIns="27432" rtlCol="0" anchor="ctr"/>
+          <a:lstStyle/>
+          <a:p>
+            <a:pPr algn="l"/>
+            <a:r>
+              <a:rPr sz="1300" b="1">
+                <a:solidFill>
+                  <a:srgbClr val="FFFFFF"/>
+                </a:solidFill>
+              </a:rPr>
+              <a:t>Sandbox (OpenShell · k8s-sig)</a:t>
+            </a:r>
+          </a:p>
+        </p:txBody>
+      </p:sp>
+      <p:sp>
+        <p:nvSpPr>
+          <p:cNvPr id="5" name="Rectangle 4"/>
+          <p:cNvSpPr/>
+          <p:nvPr/>
+        </p:nvSpPr>
+        <p:spPr>
+          <a:xfrm>
+            <a:off x="475488" y="1764792"/>
+            <a:ext cx="3621024" cy="569976"/>
+          </a:xfrm>
+          <a:prstGeom prst="rect">
+            <a:avLst/>
+          </a:prstGeom>
+          <a:solidFill>
+            <a:srgbClr val="F2F2F2"/>
+          </a:solidFill>
+          <a:ln w="6350">
+            <a:solidFill>
+              <a:srgbClr val="0B2A4A"/>
+            </a:solidFill>
+          </a:ln>
+        </p:spPr>
+        <p:style>
+          <a:lnRef idx="1">
+            <a:schemeClr val="accent1"/>
+          </a:lnRef>
+          <a:fillRef idx="3">
+            <a:schemeClr val="accent1"/>
+          </a:fillRef>
+          <a:effectRef idx="2">
+            <a:schemeClr val="accent1"/>
+          </a:effectRef>
+          <a:fontRef idx="minor">
+            <a:schemeClr val="lt1"/>
+          </a:fontRef>
+        </p:style>
+        <p:txBody>
+          <a:bodyPr wrap="square" lIns="73152" rIns="73152" rtlCol="0" anchor="ctr"/>
+          <a:lstStyle/>
+          <a:p>
+            <a:pPr algn="l"/>
+            <a:r>
+              <a:rPr sz="1100" b="1">
+                <a:solidFill>
+                  <a:srgbClr val="111111"/>
+                </a:solidFill>
+              </a:rPr>
+              <a:t>Claude Code + MCP client</a:t>
+            </a:r>
+          </a:p>
+        </p:txBody>
+      </p:sp>
+      <p:sp>
+        <p:nvSpPr>
+          <p:cNvPr id="6" name="Rectangle 5"/>
+          <p:cNvSpPr/>
+          <p:nvPr/>
+        </p:nvSpPr>
+        <p:spPr>
+          <a:xfrm>
+            <a:off x="475488" y="2389632"/>
+            <a:ext cx="3621024" cy="569976"/>
+          </a:xfrm>
+          <a:prstGeom prst="rect">
+            <a:avLst/>
+          </a:prstGeom>
+          <a:solidFill>
+            <a:srgbClr val="F2F2F2"/>
+          </a:solidFill>
+          <a:ln w="6350">
+            <a:solidFill>
+              <a:srgbClr val="0B2A4A"/>
+            </a:solidFill>
+          </a:ln>
+        </p:spPr>
+        <p:style>
+          <a:lnRef idx="1">
+            <a:schemeClr val="accent1"/>
+          </a:lnRef>
+          <a:fillRef idx="3">
+            <a:schemeClr val="accent1"/>
+          </a:fillRef>
+          <a:effectRef idx="2">
+            <a:schemeClr val="accent1"/>
+          </a:effectRef>
+          <a:fontRef idx="minor">
+            <a:schemeClr val="lt1"/>
+          </a:fontRef>
+        </p:style>
+        <p:txBody>
+          <a:bodyPr wrap="square" lIns="73152" rIns="73152" rtlCol="0" anchor="ctr"/>
+          <a:lstStyle/>
+          <a:p>
+            <a:pPr algn="l"/>
+            <a:r>
+              <a:rPr sz="1100" b="1">
+                <a:solidFill>
+                  <a:srgbClr val="111111"/>
+                </a:solidFill>
+              </a:rPr>
+              <a:t>Git · Docker/Podman · Python</a:t>
+            </a:r>
+          </a:p>
+        </p:txBody>
+      </p:sp>
+      <p:sp>
+        <p:nvSpPr>
+          <p:cNvPr id="7" name="Rectangle 6"/>
+          <p:cNvSpPr/>
+          <p:nvPr/>
+        </p:nvSpPr>
+        <p:spPr>
+          <a:xfrm>
+            <a:off x="475488" y="3014472"/>
+            <a:ext cx="3621024" cy="569976"/>
+          </a:xfrm>
+          <a:prstGeom prst="rect">
+            <a:avLst/>
+          </a:prstGeom>
+          <a:solidFill>
+            <a:srgbClr val="F2F2F2"/>
+          </a:solidFill>
+          <a:ln w="6350">
+            <a:solidFill>
+              <a:srgbClr val="0B2A4A"/>
+            </a:solidFill>
+          </a:ln>
+        </p:spPr>
+        <p:style>
+          <a:lnRef idx="1">
+            <a:schemeClr val="accent1"/>
+          </a:lnRef>
+          <a:fillRef idx="3">
+            <a:schemeClr val="accent1"/>
+          </a:fillRef>
+          <a:effectRef idx="2">
+            <a:schemeClr val="accent1"/>
+          </a:effectRef>
+          <a:fontRef idx="minor">
+            <a:schemeClr val="lt1"/>
+          </a:fontRef>
+        </p:style>
+        <p:txBody>
+          <a:bodyPr wrap="square" lIns="73152" rIns="73152" rtlCol="0" anchor="ctr"/>
+          <a:lstStyle/>
+          <a:p>
+            <a:pPr algn="l"/>
+            <a:r>
+              <a:rPr sz="1100" b="1">
+                <a:solidFill>
+                  <a:srgbClr val="111111"/>
+                </a:solidFill>
+              </a:rPr>
+              <a:t>Local GPU (optional, for dev)</a:t>
+            </a:r>
+          </a:p>
+        </p:txBody>
+      </p:sp>
+      <p:sp>
+        <p:nvSpPr>
+          <p:cNvPr id="8" name="Right Arrow 7"/>
+          <p:cNvSpPr/>
+          <p:nvPr/>
+        </p:nvSpPr>
+        <p:spPr>
+          <a:xfrm>
+            <a:off x="4297680" y="2286000"/>
+            <a:ext cx="502920" cy="365760"/>
+          </a:xfrm>
+          <a:prstGeom prst="rightArrow">
+            <a:avLst/>
+          </a:prstGeom>
+          <a:solidFill>
+            <a:srgbClr val="C93C20"/>
+          </a:solidFill>
+          <a:ln>
+            <a:noFill/>
+          </a:ln>
+        </p:spPr>
+        <p:style>
+          <a:lnRef idx="1">
+            <a:schemeClr val="accent1"/>
+          </a:lnRef>
+          <a:fillRef idx="3">
+            <a:schemeClr val="accent1"/>
+          </a:fillRef>
+          <a:effectRef idx="2">
+            <a:schemeClr val="accent1"/>
+          </a:effectRef>
+          <a:fontRef idx="minor">
+            <a:schemeClr val="lt1"/>
+          </a:fontRef>
+        </p:style>
+        <p:txBody>
+          <a:bodyPr rtlCol="0" anchor="ctr"/>
+          <a:lstStyle/>
+          <a:p>
+            <a:pPr algn="ctr"/>
+            <a:endParaRPr/>
+          </a:p>
+        </p:txBody>
+      </p:sp>
+      <p:sp>
+        <p:nvSpPr>
+          <p:cNvPr id="9" name="TextBox 8"/>
+          <p:cNvSpPr txBox="1"/>
+          <p:nvPr/>
+        </p:nvSpPr>
+        <p:spPr>
+          <a:xfrm>
+            <a:off x="4206240" y="1993392"/>
+            <a:ext cx="685800" cy="256032"/>
+          </a:xfrm>
+          <a:prstGeom prst="rect">
+            <a:avLst/>
+          </a:prstGeom>
+          <a:noFill/>
+        </p:spPr>
+        <p:txBody>
+          <a:bodyPr wrap="none">
+            <a:spAutoFit/>
+          </a:bodyPr>
+          <a:lstStyle/>
+          <a:p>
+            <a:pPr algn="l"/>
+            <a:r>
+              <a:rPr sz="1000" b="1" i="1">
+                <a:solidFill>
+                  <a:srgbClr val="C93C20"/>
+                </a:solidFill>
+              </a:rPr>
+              <a:t>MCP</a:t>
+            </a:r>
+          </a:p>
+        </p:txBody>
+      </p:sp>
+      <p:sp>
+        <p:nvSpPr>
+          <p:cNvPr id="10" name="Rounded Rectangle 9"/>
+          <p:cNvSpPr/>
+          <p:nvPr/>
+        </p:nvSpPr>
+        <p:spPr>
+          <a:xfrm>
+            <a:off x="4892040" y="1325880"/>
+            <a:ext cx="4846320" cy="2331720"/>
+          </a:xfrm>
+          <a:prstGeom prst="roundRect">
+            <a:avLst/>
+          </a:prstGeom>
+          <a:solidFill>
+            <a:srgbClr val="FAFAFA"/>
+          </a:solidFill>
+          <a:ln w="19050">
+            <a:solidFill>
+              <a:srgbClr val="0B2A4A"/>
+            </a:solidFill>
+          </a:ln>
+        </p:spPr>
+        <p:style>
+          <a:lnRef idx="1">
+            <a:schemeClr val="accent1"/>
+          </a:lnRef>
+          <a:fillRef idx="3">
+            <a:schemeClr val="accent1"/>
+          </a:fillRef>
+          <a:effectRef idx="2">
+            <a:schemeClr val="accent1"/>
+          </a:effectRef>
+          <a:fontRef idx="minor">
+            <a:schemeClr val="lt1"/>
+          </a:fontRef>
+        </p:style>
+        <p:txBody>
+          <a:bodyPr rtlCol="0" anchor="ctr"/>
+          <a:lstStyle/>
+          <a:p>
+            <a:endParaRPr/>
+          </a:p>
+        </p:txBody>
+      </p:sp>
+      <p:sp>
+        <p:nvSpPr>
+          <p:cNvPr id="11" name="Rectangle 10"/>
+          <p:cNvSpPr/>
+          <p:nvPr/>
+        </p:nvSpPr>
+        <p:spPr>
+          <a:xfrm>
+            <a:off x="4892040" y="1325880"/>
+            <a:ext cx="4846320" cy="365760"/>
+          </a:xfrm>
+          <a:prstGeom prst="rect">
+            <a:avLst/>
+          </a:prstGeom>
+          <a:solidFill>
+            <a:srgbClr val="0B2A4A"/>
+          </a:solidFill>
+          <a:ln>
+            <a:noFill/>
+          </a:ln>
+        </p:spPr>
+        <p:style>
+          <a:lnRef idx="1">
+            <a:schemeClr val="accent1"/>
+          </a:lnRef>
+          <a:fillRef idx="3">
+            <a:schemeClr val="accent1"/>
+          </a:fillRef>
+          <a:effectRef idx="2">
+            <a:schemeClr val="accent1"/>
+          </a:effectRef>
+          <a:fontRef idx="minor">
+            <a:schemeClr val="lt1"/>
+          </a:fontRef>
+        </p:style>
+        <p:txBody>
+          <a:bodyPr tIns="27432" bIns="27432" rtlCol="0" anchor="ctr"/>
+          <a:lstStyle/>
+          <a:p>
+            <a:pPr algn="l"/>
+            <a:r>
+              <a:rPr sz="1300" b="1">
+                <a:solidFill>
+                  <a:srgbClr val="FFFFFF"/>
+                </a:solidFill>
+              </a:rPr>
+              <a:t>Granite.build (gbserver)</a:t>
+            </a:r>
+          </a:p>
+        </p:txBody>
+      </p:sp>
+      <p:sp>
+        <p:nvSpPr>
+          <p:cNvPr id="12" name="Rectangle 11"/>
+          <p:cNvSpPr/>
+          <p:nvPr/>
+        </p:nvSpPr>
+        <p:spPr>
+          <a:xfrm>
+            <a:off x="5001768" y="1764792"/>
+            <a:ext cx="4626864" cy="569976"/>
+          </a:xfrm>
+          <a:prstGeom prst="rect">
+            <a:avLst/>
+          </a:prstGeom>
+          <a:solidFill>
+            <a:srgbClr val="F2F2F2"/>
+          </a:solidFill>
+          <a:ln w="6350">
+            <a:solidFill>
+              <a:srgbClr val="0B2A4A"/>
+            </a:solidFill>
+          </a:ln>
+        </p:spPr>
+        <p:style>
+          <a:lnRef idx="1">
+            <a:schemeClr val="accent1"/>
+          </a:lnRef>
+          <a:fillRef idx="3">
+            <a:schemeClr val="accent1"/>
+          </a:fillRef>
+          <a:effectRef idx="2">
+            <a:schemeClr val="accent1"/>
+          </a:effectRef>
+          <a:fontRef idx="minor">
+            <a:schemeClr val="lt1"/>
+          </a:fontRef>
+        </p:style>
+        <p:txBody>
+          <a:bodyPr wrap="square" lIns="73152" rIns="73152" rtlCol="0" anchor="ctr"/>
+          <a:lstStyle/>
+          <a:p>
+            <a:pPr algn="l"/>
+            <a:r>
+              <a:rPr sz="1100" b="1">
+                <a:solidFill>
+                  <a:srgbClr val="111111"/>
+                </a:solidFill>
+              </a:rPr>
+              <a:t>MCP Server — 10 tools (submit, status, discover, plans)</a:t>
+            </a:r>
+          </a:p>
+        </p:txBody>
+      </p:sp>
+      <p:sp>
+        <p:nvSpPr>
+          <p:cNvPr id="13" name="Rectangle 12"/>
+          <p:cNvSpPr/>
+          <p:nvPr/>
+        </p:nvSpPr>
+        <p:spPr>
+          <a:xfrm>
+            <a:off x="5001768" y="2389632"/>
+            <a:ext cx="4626864" cy="569976"/>
+          </a:xfrm>
+          <a:prstGeom prst="rect">
+            <a:avLst/>
+          </a:prstGeom>
+          <a:solidFill>
+            <a:srgbClr val="F2F2F2"/>
+          </a:solidFill>
+          <a:ln w="6350">
+            <a:solidFill>
+              <a:srgbClr val="0B2A4A"/>
+            </a:solidFill>
+          </a:ln>
+        </p:spPr>
+        <p:style>
+          <a:lnRef idx="1">
+            <a:schemeClr val="accent1"/>
+          </a:lnRef>
+          <a:fillRef idx="3">
+            <a:schemeClr val="accent1"/>
+          </a:fillRef>
+          <a:effectRef idx="2">
+            <a:schemeClr val="accent1"/>
+          </a:effectRef>
+          <a:fontRef idx="minor">
+            <a:schemeClr val="lt1"/>
+          </a:fontRef>
+        </p:style>
+        <p:txBody>
+          <a:bodyPr wrap="square" lIns="73152" rIns="73152" rtlCol="0" anchor="ctr"/>
+          <a:lstStyle/>
+          <a:p>
+            <a:pPr algn="l"/>
+            <a:r>
+              <a:rPr sz="1100" b="1">
+                <a:solidFill>
+                  <a:srgbClr val="111111"/>
+                </a:solidFill>
+              </a:rPr>
+              <a:t>BuildWatch · BuildRunner · preflight validation</a:t>
+            </a:r>
+          </a:p>
+        </p:txBody>
+      </p:sp>
+      <p:sp>
+        <p:nvSpPr>
+          <p:cNvPr id="14" name="Rectangle 13"/>
+          <p:cNvSpPr/>
+          <p:nvPr/>
+        </p:nvSpPr>
+        <p:spPr>
+          <a:xfrm>
+            <a:off x="5001768" y="3014472"/>
+            <a:ext cx="4626864" cy="569976"/>
+          </a:xfrm>
+          <a:prstGeom prst="rect">
+            <a:avLst/>
+          </a:prstGeom>
+          <a:solidFill>
+            <a:srgbClr val="F2F2F2"/>
+          </a:solidFill>
+          <a:ln w="6350">
+            <a:solidFill>
+              <a:srgbClr val="0B2A4A"/>
+            </a:solidFill>
+          </a:ln>
+        </p:spPr>
+        <p:style>
+          <a:lnRef idx="1">
+            <a:schemeClr val="accent1"/>
+          </a:lnRef>
+          <a:fillRef idx="3">
+            <a:schemeClr val="accent1"/>
+          </a:fillRef>
+          <a:effectRef idx="2">
+            <a:schemeClr val="accent1"/>
+          </a:effectRef>
+          <a:fontRef idx="minor">
+            <a:schemeClr val="lt1"/>
+          </a:fontRef>
+        </p:style>
+        <p:txBody>
+          <a:bodyPr wrap="square" lIns="73152" rIns="73152" rtlCol="0" anchor="ctr"/>
+          <a:lstStyle/>
+          <a:p>
+            <a:pPr algn="l"/>
+            <a:r>
+              <a:rPr sz="1100" b="1">
+                <a:solidFill>
+                  <a:srgbClr val="111111"/>
+                </a:solidFill>
+              </a:rPr>
+              <a:t>Storage · Artifacts · Lineage · Provenance</a:t>
+            </a:r>
+          </a:p>
+        </p:txBody>
+      </p:sp>
+      <p:sp>
+        <p:nvSpPr>
+          <p:cNvPr id="15" name="Right Arrow 14"/>
+          <p:cNvSpPr/>
+          <p:nvPr/>
+        </p:nvSpPr>
+        <p:spPr>
+          <a:xfrm>
+            <a:off x="9829800" y="2286000"/>
+            <a:ext cx="502920" cy="365760"/>
+          </a:xfrm>
+          <a:prstGeom prst="rightArrow">
+            <a:avLst/>
+          </a:prstGeom>
+          <a:solidFill>
+            <a:srgbClr val="C93C20"/>
+          </a:solidFill>
+          <a:ln>
+            <a:noFill/>
+          </a:ln>
+        </p:spPr>
+        <p:style>
+          <a:lnRef idx="1">
+            <a:schemeClr val="accent1"/>
+          </a:lnRef>
+          <a:fillRef idx="3">
+            <a:schemeClr val="accent1"/>
+          </a:fillRef>
+          <a:effectRef idx="2">
+            <a:schemeClr val="accent1"/>
+          </a:effectRef>
+          <a:fontRef idx="minor">
+            <a:schemeClr val="lt1"/>
+          </a:fontRef>
+        </p:style>
+        <p:txBody>
+          <a:bodyPr rtlCol="0" anchor="ctr"/>
+          <a:lstStyle/>
+          <a:p>
+            <a:pPr algn="ctr"/>
+            <a:endParaRPr/>
+          </a:p>
+        </p:txBody>
+      </p:sp>
+      <p:sp>
+        <p:nvSpPr>
+          <p:cNvPr id="16" name="TextBox 15"/>
+          <p:cNvSpPr txBox="1"/>
+          <p:nvPr/>
+        </p:nvSpPr>
+        <p:spPr>
+          <a:xfrm>
+            <a:off x="9738360" y="1993392"/>
+            <a:ext cx="685800" cy="256032"/>
+          </a:xfrm>
+          <a:prstGeom prst="rect">
+            <a:avLst/>
+          </a:prstGeom>
+          <a:noFill/>
+        </p:spPr>
+        <p:txBody>
+          <a:bodyPr wrap="none">
+            <a:spAutoFit/>
+          </a:bodyPr>
+          <a:lstStyle/>
+          <a:p>
+            <a:pPr algn="l"/>
+            <a:r>
+              <a:rPr sz="1000" b="1" i="1">
+                <a:solidFill>
+                  <a:srgbClr val="C93C20"/>
+                </a:solidFill>
+              </a:rPr>
+              <a:t>dispatch</a:t>
+            </a:r>
+          </a:p>
+        </p:txBody>
+      </p:sp>
+      <p:sp>
+        <p:nvSpPr>
+          <p:cNvPr id="17" name="Rounded Rectangle 16"/>
+          <p:cNvSpPr/>
+          <p:nvPr/>
+        </p:nvSpPr>
+        <p:spPr>
+          <a:xfrm>
+            <a:off x="10424160" y="1325880"/>
+            <a:ext cx="1417320" cy="2331720"/>
+          </a:xfrm>
+          <a:prstGeom prst="roundRect">
+            <a:avLst/>
+          </a:prstGeom>
+          <a:solidFill>
+            <a:srgbClr val="FAFAFA"/>
+          </a:solidFill>
+          <a:ln w="19050">
+            <a:solidFill>
+              <a:srgbClr val="0B2A4A"/>
+            </a:solidFill>
+          </a:ln>
+        </p:spPr>
+        <p:style>
+          <a:lnRef idx="1">
+            <a:schemeClr val="accent1"/>
+          </a:lnRef>
+          <a:fillRef idx="3">
+            <a:schemeClr val="accent1"/>
+          </a:fillRef>
+          <a:effectRef idx="2">
+            <a:schemeClr val="accent1"/>
+          </a:effectRef>
+          <a:fontRef idx="minor">
+            <a:schemeClr val="lt1"/>
+          </a:fontRef>
+        </p:style>
+        <p:txBody>
+          <a:bodyPr rtlCol="0" anchor="ctr"/>
+          <a:lstStyle/>
+          <a:p>
+            <a:endParaRPr/>
+          </a:p>
+        </p:txBody>
+      </p:sp>
+      <p:sp>
+        <p:nvSpPr>
+          <p:cNvPr id="18" name="Rectangle 17"/>
+          <p:cNvSpPr/>
+          <p:nvPr/>
+        </p:nvSpPr>
+        <p:spPr>
+          <a:xfrm>
+            <a:off x="10424160" y="1325880"/>
+            <a:ext cx="1417320" cy="365760"/>
+          </a:xfrm>
+          <a:prstGeom prst="rect">
+            <a:avLst/>
+          </a:prstGeom>
+          <a:solidFill>
+            <a:srgbClr val="0B2A4A"/>
+          </a:solidFill>
+          <a:ln>
+            <a:noFill/>
+          </a:ln>
+        </p:spPr>
+        <p:style>
+          <a:lnRef idx="1">
+            <a:schemeClr val="accent1"/>
+          </a:lnRef>
+          <a:fillRef idx="3">
+            <a:schemeClr val="accent1"/>
+          </a:fillRef>
+          <a:effectRef idx="2">
+            <a:schemeClr val="accent1"/>
+          </a:effectRef>
+          <a:fontRef idx="minor">
+            <a:schemeClr val="lt1"/>
+          </a:fontRef>
+        </p:style>
+        <p:txBody>
+          <a:bodyPr tIns="27432" bIns="27432" rtlCol="0" anchor="ctr"/>
+          <a:lstStyle/>
+          <a:p>
+            <a:pPr algn="l"/>
+            <a:r>
+              <a:rPr sz="1300" b="1">
+                <a:solidFill>
+                  <a:srgbClr val="FFFFFF"/>
+                </a:solidFill>
+              </a:rPr>
+              <a:t>Backends</a:t>
+            </a:r>
+          </a:p>
+        </p:txBody>
+      </p:sp>
+      <p:sp>
+        <p:nvSpPr>
+          <p:cNvPr id="19" name="Rectangle 18"/>
+          <p:cNvSpPr/>
+          <p:nvPr/>
+        </p:nvSpPr>
+        <p:spPr>
+          <a:xfrm>
+            <a:off x="10533888" y="1764792"/>
+            <a:ext cx="1197864" cy="569976"/>
+          </a:xfrm>
+          <a:prstGeom prst="rect">
+            <a:avLst/>
+          </a:prstGeom>
+          <a:solidFill>
+            <a:srgbClr val="F2F2F2"/>
+          </a:solidFill>
+          <a:ln w="6350">
+            <a:solidFill>
+              <a:srgbClr val="0B2A4A"/>
+            </a:solidFill>
+          </a:ln>
+        </p:spPr>
+        <p:style>
+          <a:lnRef idx="1">
+            <a:schemeClr val="accent1"/>
+          </a:lnRef>
+          <a:fillRef idx="3">
+            <a:schemeClr val="accent1"/>
+          </a:fillRef>
+          <a:effectRef idx="2">
+            <a:schemeClr val="accent1"/>
+          </a:effectRef>
+          <a:fontRef idx="minor">
+            <a:schemeClr val="lt1"/>
+          </a:fontRef>
+        </p:style>
+        <p:txBody>
+          <a:bodyPr wrap="square" lIns="73152" rIns="73152" rtlCol="0" anchor="ctr"/>
+          <a:lstStyle/>
+          <a:p>
+            <a:pPr algn="l"/>
+            <a:r>
+              <a:rPr sz="1100" b="1">
+                <a:solidFill>
+                  <a:srgbClr val="111111"/>
+                </a:solidFill>
+              </a:rPr>
+              <a:t>Docker / Podman</a:t>
+            </a:r>
+          </a:p>
+        </p:txBody>
+      </p:sp>
+      <p:sp>
+        <p:nvSpPr>
+          <p:cNvPr id="20" name="Rectangle 19"/>
+          <p:cNvSpPr/>
+          <p:nvPr/>
+        </p:nvSpPr>
+        <p:spPr>
+          <a:xfrm>
+            <a:off x="10533888" y="2389632"/>
+            <a:ext cx="1197864" cy="569976"/>
+          </a:xfrm>
+          <a:prstGeom prst="rect">
+            <a:avLst/>
+          </a:prstGeom>
+          <a:solidFill>
+            <a:srgbClr val="F2F2F2"/>
+          </a:solidFill>
+          <a:ln w="6350">
+            <a:solidFill>
+              <a:srgbClr val="0B2A4A"/>
+            </a:solidFill>
+          </a:ln>
+        </p:spPr>
+        <p:style>
+          <a:lnRef idx="1">
+            <a:schemeClr val="accent1"/>
+          </a:lnRef>
+          <a:fillRef idx="3">
+            <a:schemeClr val="accent1"/>
+          </a:fillRef>
+          <a:effectRef idx="2">
+            <a:schemeClr val="accent1"/>
+          </a:effectRef>
+          <a:fontRef idx="minor">
+            <a:schemeClr val="lt1"/>
+          </a:fontRef>
+        </p:style>
+        <p:txBody>
+          <a:bodyPr wrap="square" lIns="73152" rIns="73152" rtlCol="0" anchor="ctr"/>
+          <a:lstStyle/>
+          <a:p>
+            <a:pPr algn="l"/>
+            <a:r>
+              <a:rPr sz="1100" b="1">
+                <a:solidFill>
+                  <a:srgbClr val="111111"/>
+                </a:solidFill>
+              </a:rPr>
+              <a:t>RunPod (cloud)</a:t>
+            </a:r>
+          </a:p>
+        </p:txBody>
+      </p:sp>
+      <p:sp>
+        <p:nvSpPr>
+          <p:cNvPr id="21" name="Rectangle 20"/>
+          <p:cNvSpPr/>
+          <p:nvPr/>
+        </p:nvSpPr>
+        <p:spPr>
+          <a:xfrm>
+            <a:off x="10533888" y="3014472"/>
+            <a:ext cx="1197864" cy="569976"/>
+          </a:xfrm>
+          <a:prstGeom prst="rect">
+            <a:avLst/>
+          </a:prstGeom>
+          <a:solidFill>
+            <a:srgbClr val="F2F2F2"/>
+          </a:solidFill>
+          <a:ln w="6350">
+            <a:solidFill>
+              <a:srgbClr val="0B2A4A"/>
+            </a:solidFill>
+          </a:ln>
+        </p:spPr>
+        <p:style>
+          <a:lnRef idx="1">
+            <a:schemeClr val="accent1"/>
+          </a:lnRef>
+          <a:fillRef idx="3">
+            <a:schemeClr val="accent1"/>
+          </a:fillRef>
+          <a:effectRef idx="2">
+            <a:schemeClr val="accent1"/>
+          </a:effectRef>
+          <a:fontRef idx="minor">
+            <a:schemeClr val="lt1"/>
+          </a:fontRef>
+        </p:style>
+        <p:txBody>
+          <a:bodyPr wrap="square" lIns="73152" rIns="73152" rtlCol="0" anchor="ctr"/>
+          <a:lstStyle/>
+          <a:p>
+            <a:pPr algn="l"/>
+            <a:r>
+              <a:rPr sz="1100" b="1">
+                <a:solidFill>
+                  <a:srgbClr val="111111"/>
+                </a:solidFill>
+              </a:rPr>
+              <a:t>SkyPilot · k8s · Slurm</a:t>
+            </a:r>
+          </a:p>
+        </p:txBody>
+      </p:sp>
+      <p:sp>
+        <p:nvSpPr>
+          <p:cNvPr id="22" name="TextBox 21"/>
+          <p:cNvSpPr txBox="1"/>
+          <p:nvPr/>
+        </p:nvSpPr>
+        <p:spPr>
+          <a:xfrm>
+            <a:off x="365760" y="3703320"/>
+            <a:ext cx="11521440" cy="274320"/>
+          </a:xfrm>
+          <a:prstGeom prst="rect">
+            <a:avLst/>
+          </a:prstGeom>
+          <a:noFill/>
+        </p:spPr>
+        <p:txBody>
+          <a:bodyPr wrap="none">
+            <a:spAutoFit/>
+          </a:bodyPr>
+          <a:lstStyle/>
+          <a:p>
+            <a:pPr algn="l"/>
+            <a:r>
+              <a:rPr sz="1100" i="1">
+                <a:solidFill>
+                  <a:srgbClr val="555555"/>
+                </a:solidFill>
+              </a:rPr>
+              <a:t>Backends fetch code (git), images (registry), and artifacts (S3 · HF · COS) directly — never through MCP or the agent.</a:t>
+            </a:r>
+          </a:p>
+        </p:txBody>
+      </p:sp>
+      <p:sp>
+        <p:nvSpPr>
+          <p:cNvPr id="23" name="TextBox 22"/>
+          <p:cNvSpPr txBox="1"/>
+          <p:nvPr/>
+        </p:nvSpPr>
+        <p:spPr>
+          <a:xfrm>
+            <a:off x="457200" y="4069080"/>
+            <a:ext cx="5669280" cy="2148840"/>
+          </a:xfrm>
+          <a:prstGeom prst="rect">
+            <a:avLst/>
+          </a:prstGeom>
+          <a:noFill/>
+        </p:spPr>
+        <p:txBody>
+          <a:bodyPr wrap="square">
+            <a:spAutoFit/>
+          </a:bodyPr>
+          <a:lstStyle/>
+          <a:p>
+            <a:r>
+              <a:rPr sz="1600" b="1">
+                <a:solidFill>
+                  <a:srgbClr val="0B2A4A"/>
+                </a:solidFill>
+              </a:rPr>
+              <a:t>a) Safe, persistent agent sandbox</a:t>
+            </a:r>
+          </a:p>
+          <a:p>
+            <a:r>
+              <a:rPr sz="1200">
+                <a:solidFill>
+                  <a:srgbClr val="111111"/>
+                </a:solidFill>
+              </a:rPr>
+              <a:t>• Persistent container, decoupled from laptop — survives across sessions</a:t>
+            </a:r>
+          </a:p>
+          <a:p>
+            <a:r>
+              <a:rPr sz="1200">
+                <a:solidFill>
+                  <a:srgbClr val="111111"/>
+                </a:solidFill>
+              </a:rPr>
+              <a:t>• Local GPU for prototyping before scaling out</a:t>
+            </a:r>
+          </a:p>
+          <a:p>
+            <a:r>
+              <a:rPr sz="1200">
+                <a:solidFill>
+                  <a:srgbClr val="111111"/>
+                </a:solidFill>
+              </a:rPr>
+              <a:t>• Safe execution: preflight checks, space-scoped credentials + artifacts</a:t>
+            </a:r>
+          </a:p>
+        </p:txBody>
+      </p:sp>
+      <p:sp>
+        <p:nvSpPr>
+          <p:cNvPr id="24" name="TextBox 23"/>
+          <p:cNvSpPr txBox="1"/>
+          <p:nvPr/>
+        </p:nvSpPr>
+        <p:spPr>
+          <a:xfrm>
+            <a:off x="6355080" y="4069080"/>
+            <a:ext cx="5486400" cy="2148840"/>
+          </a:xfrm>
+          <a:prstGeom prst="rect">
+            <a:avLst/>
+          </a:prstGeom>
+          <a:noFill/>
+        </p:spPr>
+        <p:txBody>
+          <a:bodyPr wrap="square">
+            <a:spAutoFit/>
+          </a:bodyPr>
+          <a:lstStyle/>
+          <a:p>
+            <a:r>
+              <a:rPr sz="1600" b="1">
+                <a:solidFill>
+                  <a:srgbClr val="0B2A4A"/>
+                </a:solidFill>
+              </a:rPr>
+              <a:t>b) Granite.build as scale mediation</a:t>
+            </a:r>
+          </a:p>
+          <a:p>
+            <a:r>
+              <a:rPr sz="1200">
+                <a:solidFill>
+                  <a:srgbClr val="111111"/>
+                </a:solidFill>
+              </a:rPr>
+              <a:t>• Control plane only — specs pin commit SHAs + image URIs</a:t>
+            </a:r>
+          </a:p>
+          <a:p>
+            <a:r>
+              <a:rPr sz="1200">
+                <a:solidFill>
+                  <a:srgbClr val="111111"/>
+                </a:solidFill>
+              </a:rPr>
+              <a:t>• 10 MCP tools: discover steps/envs/quotas, submit, poll, retrieve</a:t>
+            </a:r>
+          </a:p>
+          <a:p>
+            <a:r>
+              <a:rPr sz="1200">
+                <a:solidFill>
+                  <a:srgbClr val="111111"/>
+                </a:solidFill>
+              </a:rPr>
+              <a:t>• Deterministic runs; artifact lineage and provenance by construction</a:t>
+            </a:r>
+          </a:p>
+        </p:txBody>
+      </p:sp>
+      <p:sp>
+        <p:nvSpPr>
+          <p:cNvPr id="25" name="Rectangle 24"/>
+          <p:cNvSpPr/>
+          <p:nvPr/>
+        </p:nvSpPr>
+        <p:spPr>
+          <a:xfrm>
+            <a:off x="0" y="6309360"/>
+            <a:ext cx="12188952" cy="548640"/>
+          </a:xfrm>
+          <a:prstGeom prst="rect">
+            <a:avLst/>
+          </a:prstGeom>
+          <a:solidFill>
+            <a:srgbClr val="0B2A4A"/>
+          </a:solidFill>
+          <a:ln>
+            <a:noFill/>
+          </a:ln>
+        </p:spPr>
+        <p:style>
+          <a:lnRef idx="1">
+            <a:schemeClr val="accent1"/>
+          </a:lnRef>
+          <a:fillRef idx="3">
+            <a:schemeClr val="accent1"/>
+          </a:fillRef>
+          <a:effectRef idx="2">
+            <a:schemeClr val="accent1"/>
+          </a:effectRef>
+          <a:fontRef idx="minor">
+            <a:schemeClr val="lt1"/>
+          </a:fontRef>
+        </p:style>
+        <p:txBody>
+          <a:bodyPr lIns="274320" rIns="274320" rtlCol="0" anchor="ctr"/>
           <a:lstStyle/>
           <a:p>
             <a:pPr algn="l"/>
@@ -4128,7 +5253,7 @@
 </file>
 
 <file path=ppt/slides/slide3.xml><?xml version="1.0" encoding="utf-8"?>
-<p:sld xmlns:a="http://schemas.openxmlformats.org/drawingml/2006/main" xmlns:p="http://schemas.openxmlformats.org/presentationml/2006/main" xmlns:r="http://schemas.openxmlformats.org/officeDocument/2006/relationships">
+<p:sld xmlns:a="http://schemas.openxmlformats.org/drawingml/2006/main" xmlns:r="http://schemas.openxmlformats.org/officeDocument/2006/relationships" xmlns:p="http://schemas.openxmlformats.org/presentationml/2006/main">
   <p:cSld>
     <p:spTree>
       <p:nvGrpSpPr>
@@ -4136,7 +5261,14 @@
         <p:cNvGrpSpPr/>
         <p:nvPr/>
       </p:nvGrpSpPr>
-      <p:grpSpPr/>
+      <p:grpSpPr>
+        <a:xfrm>
+          <a:off x="0" y="0"/>
+          <a:ext cx="0" cy="0"/>
+          <a:chOff x="0" y="0"/>
+          <a:chExt cx="0" cy="0"/>
+        </a:xfrm>
+      </p:grpSpPr>
       <p:sp>
         <p:nvSpPr>
           <p:cNvPr id="2" name="TextBox 1"/>
@@ -4165,7 +5297,7 @@
                   <a:srgbClr val="0B2A4A"/>
                 </a:solidFill>
               </a:rPr>
-              <a:t>Flight plans + logbooks — external memory for experiments</a:t>
+              <a:t>From sandbox to at-scale — packaging + submission</a:t>
             </a:r>
           </a:p>
           <a:p>
@@ -4175,210 +5307,23 @@
                   <a:srgbClr val="555555"/>
                 </a:solidFill>
               </a:rPr>
-              <a:t>The intent, the methodology, and the daily record — all durable and searchable</a:t>
-            </a:r>
-          </a:p>
-        </p:txBody>
-      </p:sp>
-      <p:sp>
-        <p:nvSpPr>
-          <p:cNvPr id="3" name="TextBox 2"/>
-          <p:cNvSpPr txBox="1"/>
-          <p:nvPr/>
-        </p:nvSpPr>
-        <p:spPr>
-          <a:xfrm>
-            <a:off x="457200" y="1325880"/>
-            <a:ext cx="5669280" cy="4754880"/>
-          </a:xfrm>
-          <a:prstGeom prst="rect">
-            <a:avLst/>
-          </a:prstGeom>
-          <a:noFill/>
-        </p:spPr>
-        <p:txBody>
-          <a:bodyPr wrap="square">
-            <a:spAutoFit/>
-          </a:bodyPr>
-          <a:lstStyle/>
-          <a:p>
-            <a:r>
-              <a:rPr sz="1600" b="1">
-                <a:solidFill>
-                  <a:srgbClr val="0B2A4A"/>
-                </a:solidFill>
-              </a:rPr>
-              <a:t>Flight plans: durable intent</a:t>
-            </a:r>
-          </a:p>
-          <a:p>
-            <a:pPr/>
-            <a:r>
-              <a:rPr sz="1300">
-                <a:solidFill>
-                  <a:srgbClr val="111111"/>
-                </a:solidFill>
-              </a:rPr>
-              <a:t>• Co-authored with the agent in the sandbox; captures the what and the why</a:t>
-            </a:r>
-          </a:p>
-          <a:p>
-            <a:pPr/>
-            <a:r>
-              <a:rPr sz="1300">
-                <a:solidFill>
-                  <a:srgbClr val="111111"/>
-                </a:solidFill>
-              </a:rPr>
-              <a:t>• Level 1 — Intent (human narrative)</a:t>
-            </a:r>
-          </a:p>
-          <a:p>
-            <a:pPr/>
-            <a:r>
-              <a:rPr sz="1300">
-                <a:solidFill>
-                  <a:srgbClr val="111111"/>
-                </a:solidFill>
-              </a:rPr>
-              <a:t>• Level 2 — Methodology (structured steps, dependencies)</a:t>
-            </a:r>
-          </a:p>
-          <a:p>
-            <a:pPr/>
-            <a:r>
-              <a:rPr sz="1300">
-                <a:solidFill>
-                  <a:srgbClr val="111111"/>
-                </a:solidFill>
-              </a:rPr>
-              <a:t>• Level 3 — Execution (build.yaml, derived at submit time)</a:t>
-            </a:r>
-          </a:p>
-          <a:p>
-            <a:pPr/>
-            <a:r>
-              <a:rPr sz="1300">
-                <a:solidFill>
-                  <a:srgbClr val="111111"/>
-                </a:solidFill>
-              </a:rPr>
-              <a:t>• Append-only revision history; one plan spawns many builds as you iterate</a:t>
-            </a:r>
-          </a:p>
-          <a:p>
-            <a:pPr/>
-            <a:r>
-              <a:rPr sz="1300">
-                <a:solidFill>
-                  <a:srgbClr val="111111"/>
-                </a:solidFill>
-              </a:rPr>
-              <a:t>• Every job carries plan_id → build → artifact — provenance by construction</a:t>
-            </a:r>
-          </a:p>
-        </p:txBody>
-      </p:sp>
-      <p:sp>
-        <p:nvSpPr>
-          <p:cNvPr id="4" name="TextBox 3"/>
-          <p:cNvSpPr txBox="1"/>
-          <p:nvPr/>
-        </p:nvSpPr>
-        <p:spPr>
-          <a:xfrm>
-            <a:off x="6355080" y="1325880"/>
-            <a:ext cx="5486400" cy="4754880"/>
-          </a:xfrm>
-          <a:prstGeom prst="rect">
-            <a:avLst/>
-          </a:prstGeom>
-          <a:noFill/>
-        </p:spPr>
-        <p:txBody>
-          <a:bodyPr wrap="square">
-            <a:spAutoFit/>
-          </a:bodyPr>
-          <a:lstStyle/>
-          <a:p>
-            <a:r>
-              <a:rPr sz="1600" b="1">
-                <a:solidFill>
-                  <a:srgbClr val="0B2A4A"/>
-                </a:solidFill>
-              </a:rPr>
-              <a:t>Logbooks: durable history</a:t>
-            </a:r>
-          </a:p>
-          <a:p>
-            <a:pPr/>
-            <a:r>
-              <a:rPr sz="1300">
-                <a:solidFill>
-                  <a:srgbClr val="111111"/>
-                </a:solidFill>
-              </a:rPr>
-              <a:t>• Daily record of what was achieved, decided, or ruled out — not raw transcripts</a:t>
-            </a:r>
-          </a:p>
-          <a:p>
-            <a:pPr/>
-            <a:r>
-              <a:rPr sz="1300">
-                <a:solidFill>
-                  <a:srgbClr val="111111"/>
-                </a:solidFill>
-              </a:rPr>
-              <a:t>• Searchable, shareable, persistent external record of agent sessions</a:t>
-            </a:r>
-          </a:p>
-          <a:p>
-            <a:pPr/>
-            <a:r>
-              <a:rPr sz="1300">
-                <a:solidFill>
-                  <a:srgbClr val="111111"/>
-                </a:solidFill>
-              </a:rPr>
-              <a:t>• Future retrieval: answer months later why micro_batch=1 or why MLA over GQA</a:t>
-            </a:r>
-          </a:p>
-          <a:p>
-            <a:pPr/>
-            <a:r>
-              <a:rPr sz="1300">
-                <a:solidFill>
-                  <a:srgbClr val="111111"/>
-                </a:solidFill>
-              </a:rPr>
-              <a:t>• Example: the 475-SSH audit was reconstructed from session transcripts — logbooks make this first-class</a:t>
-            </a:r>
-          </a:p>
-          <a:p>
-            <a:pPr/>
-            <a:r>
-              <a:rPr sz="1300">
-                <a:solidFill>
-                  <a:srgbClr val="111111"/>
-                </a:solidFill>
-              </a:rPr>
-              <a:t>• Pairs with flight plans: the plan says what we meant to do, the logbook says what actually happened</a:t>
-            </a:r>
-          </a:p>
-        </p:txBody>
-      </p:sp>
-      <p:sp>
-        <p:nvSpPr>
-          <p:cNvPr id="5" name="Rectangle 4"/>
+              <a:t>Claude Code helps with development, packaging, AND the build.yaml submission</a:t>
+            </a:r>
+          </a:p>
+        </p:txBody>
+      </p:sp>
+      <p:sp>
+        <p:nvSpPr>
+          <p:cNvPr id="3" name="Rounded Rectangle 2"/>
           <p:cNvSpPr/>
           <p:nvPr/>
         </p:nvSpPr>
         <p:spPr>
           <a:xfrm>
-            <a:off x="0" y="6309360"/>
-            <a:ext cx="12188952" cy="548640"/>
-          </a:xfrm>
-          <a:prstGeom prst="rect">
+            <a:off x="2898648" y="1325880"/>
+            <a:ext cx="6400800" cy="502920"/>
+          </a:xfrm>
+          <a:prstGeom prst="roundRect">
             <a:avLst/>
           </a:prstGeom>
           <a:solidFill>
@@ -4403,17 +5348,956 @@
           </a:fontRef>
         </p:style>
         <p:txBody>
-          <a:bodyPr rtlCol="0" anchor="ctr" lIns="274320" rIns="274320"/>
+          <a:bodyPr wrap="square" rtlCol="0" anchor="ctr"/>
           <a:lstStyle/>
           <a:p>
             <a:pPr algn="l"/>
             <a:r>
+              <a:rPr sz="1300" b="1" i="0">
+                <a:solidFill>
+                  <a:srgbClr val="FFFFFF"/>
+                </a:solidFill>
+              </a:rPr>
+              <a:t>Local dev iterations complete in the sandbox — code runs end-to-end</a:t>
+            </a:r>
+          </a:p>
+        </p:txBody>
+      </p:sp>
+      <p:sp>
+        <p:nvSpPr>
+          <p:cNvPr id="4" name="Down Arrow 3"/>
+          <p:cNvSpPr/>
+          <p:nvPr/>
+        </p:nvSpPr>
+        <p:spPr>
+          <a:xfrm>
+            <a:off x="3017520" y="1920240"/>
+            <a:ext cx="320040" cy="274320"/>
+          </a:xfrm>
+          <a:prstGeom prst="downArrow">
+            <a:avLst/>
+          </a:prstGeom>
+          <a:solidFill>
+            <a:srgbClr val="C93C20"/>
+          </a:solidFill>
+          <a:ln>
+            <a:noFill/>
+          </a:ln>
+        </p:spPr>
+        <p:style>
+          <a:lnRef idx="1">
+            <a:schemeClr val="accent1"/>
+          </a:lnRef>
+          <a:fillRef idx="3">
+            <a:schemeClr val="accent1"/>
+          </a:fillRef>
+          <a:effectRef idx="2">
+            <a:schemeClr val="accent1"/>
+          </a:effectRef>
+          <a:fontRef idx="minor">
+            <a:schemeClr val="lt1"/>
+          </a:fontRef>
+        </p:style>
+        <p:txBody>
+          <a:bodyPr rtlCol="0" anchor="ctr"/>
+          <a:lstStyle/>
+          <a:p>
+            <a:pPr algn="ctr"/>
+            <a:endParaRPr/>
+          </a:p>
+        </p:txBody>
+      </p:sp>
+      <p:sp>
+        <p:nvSpPr>
+          <p:cNvPr id="5" name="Down Arrow 4"/>
+          <p:cNvSpPr/>
+          <p:nvPr/>
+        </p:nvSpPr>
+        <p:spPr>
+          <a:xfrm>
+            <a:off x="8869680" y="1920240"/>
+            <a:ext cx="320040" cy="274320"/>
+          </a:xfrm>
+          <a:prstGeom prst="downArrow">
+            <a:avLst/>
+          </a:prstGeom>
+          <a:solidFill>
+            <a:srgbClr val="C93C20"/>
+          </a:solidFill>
+          <a:ln>
+            <a:noFill/>
+          </a:ln>
+        </p:spPr>
+        <p:style>
+          <a:lnRef idx="1">
+            <a:schemeClr val="accent1"/>
+          </a:lnRef>
+          <a:fillRef idx="3">
+            <a:schemeClr val="accent1"/>
+          </a:fillRef>
+          <a:effectRef idx="2">
+            <a:schemeClr val="accent1"/>
+          </a:effectRef>
+          <a:fontRef idx="minor">
+            <a:schemeClr val="lt1"/>
+          </a:fontRef>
+        </p:style>
+        <p:txBody>
+          <a:bodyPr rtlCol="0" anchor="ctr"/>
+          <a:lstStyle/>
+          <a:p>
+            <a:pPr algn="ctr"/>
+            <a:endParaRPr/>
+          </a:p>
+        </p:txBody>
+      </p:sp>
+      <p:sp>
+        <p:nvSpPr>
+          <p:cNvPr id="6" name="Rounded Rectangle 5"/>
+          <p:cNvSpPr/>
+          <p:nvPr/>
+        </p:nvSpPr>
+        <p:spPr>
+          <a:xfrm>
+            <a:off x="365760" y="2286000"/>
+            <a:ext cx="5669280" cy="2468880"/>
+          </a:xfrm>
+          <a:prstGeom prst="roundRect">
+            <a:avLst/>
+          </a:prstGeom>
+          <a:solidFill>
+            <a:srgbClr val="FAFAFA"/>
+          </a:solidFill>
+          <a:ln w="19050">
+            <a:solidFill>
+              <a:srgbClr val="0B2A4A"/>
+            </a:solidFill>
+          </a:ln>
+        </p:spPr>
+        <p:style>
+          <a:lnRef idx="1">
+            <a:schemeClr val="accent1"/>
+          </a:lnRef>
+          <a:fillRef idx="3">
+            <a:schemeClr val="accent1"/>
+          </a:fillRef>
+          <a:effectRef idx="2">
+            <a:schemeClr val="accent1"/>
+          </a:effectRef>
+          <a:fontRef idx="minor">
+            <a:schemeClr val="lt1"/>
+          </a:fontRef>
+        </p:style>
+        <p:txBody>
+          <a:bodyPr rtlCol="0" anchor="ctr"/>
+          <a:lstStyle/>
+          <a:p>
+            <a:endParaRPr/>
+          </a:p>
+        </p:txBody>
+      </p:sp>
+      <p:sp>
+        <p:nvSpPr>
+          <p:cNvPr id="7" name="Rectangle 6"/>
+          <p:cNvSpPr/>
+          <p:nvPr/>
+        </p:nvSpPr>
+        <p:spPr>
+          <a:xfrm>
+            <a:off x="365760" y="2286000"/>
+            <a:ext cx="5669280" cy="365760"/>
+          </a:xfrm>
+          <a:prstGeom prst="rect">
+            <a:avLst/>
+          </a:prstGeom>
+          <a:solidFill>
+            <a:srgbClr val="0B2A4A"/>
+          </a:solidFill>
+          <a:ln>
+            <a:noFill/>
+          </a:ln>
+        </p:spPr>
+        <p:style>
+          <a:lnRef idx="1">
+            <a:schemeClr val="accent1"/>
+          </a:lnRef>
+          <a:fillRef idx="3">
+            <a:schemeClr val="accent1"/>
+          </a:fillRef>
+          <a:effectRef idx="2">
+            <a:schemeClr val="accent1"/>
+          </a:effectRef>
+          <a:fontRef idx="minor">
+            <a:schemeClr val="lt1"/>
+          </a:fontRef>
+        </p:style>
+        <p:txBody>
+          <a:bodyPr tIns="27432" bIns="27432" rtlCol="0" anchor="ctr"/>
+          <a:lstStyle/>
+          <a:p>
+            <a:pPr algn="l"/>
+            <a:r>
+              <a:rPr sz="1300" b="1">
+                <a:solidFill>
+                  <a:srgbClr val="FFFFFF"/>
+                </a:solidFill>
+              </a:rPr>
+              <a:t>Path A — Git push → Bring-Your-Own-Step (BYOS)</a:t>
+            </a:r>
+          </a:p>
+        </p:txBody>
+      </p:sp>
+      <p:sp>
+        <p:nvSpPr>
+          <p:cNvPr id="8" name="Rectangle 7"/>
+          <p:cNvSpPr/>
+          <p:nvPr/>
+        </p:nvSpPr>
+        <p:spPr>
+          <a:xfrm>
+            <a:off x="475488" y="2724912"/>
+            <a:ext cx="5449824" cy="615696"/>
+          </a:xfrm>
+          <a:prstGeom prst="rect">
+            <a:avLst/>
+          </a:prstGeom>
+          <a:solidFill>
+            <a:srgbClr val="F2F2F2"/>
+          </a:solidFill>
+          <a:ln w="6350">
+            <a:solidFill>
+              <a:srgbClr val="0B2A4A"/>
+            </a:solidFill>
+          </a:ln>
+        </p:spPr>
+        <p:style>
+          <a:lnRef idx="1">
+            <a:schemeClr val="accent1"/>
+          </a:lnRef>
+          <a:fillRef idx="3">
+            <a:schemeClr val="accent1"/>
+          </a:fillRef>
+          <a:effectRef idx="2">
+            <a:schemeClr val="accent1"/>
+          </a:effectRef>
+          <a:fontRef idx="minor">
+            <a:schemeClr val="lt1"/>
+          </a:fontRef>
+        </p:style>
+        <p:txBody>
+          <a:bodyPr wrap="square" lIns="73152" rIns="73152" rtlCol="0" anchor="ctr"/>
+          <a:lstStyle/>
+          <a:p>
+            <a:pPr algn="l"/>
+            <a:r>
+              <a:rPr sz="1100" b="1">
+                <a:solidFill>
+                  <a:srgbClr val="111111"/>
+                </a:solidFill>
+              </a:rPr>
+              <a:t>Commit &amp; push to GitHub (pin commit SHA, not a branch ref)</a:t>
+            </a:r>
+          </a:p>
+        </p:txBody>
+      </p:sp>
+      <p:sp>
+        <p:nvSpPr>
+          <p:cNvPr id="9" name="Rectangle 8"/>
+          <p:cNvSpPr/>
+          <p:nvPr/>
+        </p:nvSpPr>
+        <p:spPr>
+          <a:xfrm>
+            <a:off x="475488" y="3395472"/>
+            <a:ext cx="5449824" cy="615696"/>
+          </a:xfrm>
+          <a:prstGeom prst="rect">
+            <a:avLst/>
+          </a:prstGeom>
+          <a:solidFill>
+            <a:srgbClr val="F2F2F2"/>
+          </a:solidFill>
+          <a:ln w="6350">
+            <a:solidFill>
+              <a:srgbClr val="0B2A4A"/>
+            </a:solidFill>
+          </a:ln>
+        </p:spPr>
+        <p:style>
+          <a:lnRef idx="1">
+            <a:schemeClr val="accent1"/>
+          </a:lnRef>
+          <a:fillRef idx="3">
+            <a:schemeClr val="accent1"/>
+          </a:fillRef>
+          <a:effectRef idx="2">
+            <a:schemeClr val="accent1"/>
+          </a:effectRef>
+          <a:fontRef idx="minor">
+            <a:schemeClr val="lt1"/>
+          </a:fontRef>
+        </p:style>
+        <p:txBody>
+          <a:bodyPr wrap="square" lIns="73152" rIns="73152" rtlCol="0" anchor="ctr"/>
+          <a:lstStyle/>
+          <a:p>
+            <a:pPr algn="l"/>
+            <a:r>
+              <a:rPr sz="1100" b="1">
+                <a:solidFill>
+                  <a:srgbClr val="111111"/>
+                </a:solidFill>
+              </a:rPr>
+              <a:t>Claude Code authors a custom_code step (BYOS) referencing github_url</a:t>
+            </a:r>
+          </a:p>
+        </p:txBody>
+      </p:sp>
+      <p:sp>
+        <p:nvSpPr>
+          <p:cNvPr id="10" name="Rectangle 9"/>
+          <p:cNvSpPr/>
+          <p:nvPr/>
+        </p:nvSpPr>
+        <p:spPr>
+          <a:xfrm>
+            <a:off x="475488" y="4066032"/>
+            <a:ext cx="5449824" cy="615696"/>
+          </a:xfrm>
+          <a:prstGeom prst="rect">
+            <a:avLst/>
+          </a:prstGeom>
+          <a:solidFill>
+            <a:srgbClr val="F2F2F2"/>
+          </a:solidFill>
+          <a:ln w="6350">
+            <a:solidFill>
+              <a:srgbClr val="0B2A4A"/>
+            </a:solidFill>
+          </a:ln>
+        </p:spPr>
+        <p:style>
+          <a:lnRef idx="1">
+            <a:schemeClr val="accent1"/>
+          </a:lnRef>
+          <a:fillRef idx="3">
+            <a:schemeClr val="accent1"/>
+          </a:fillRef>
+          <a:effectRef idx="2">
+            <a:schemeClr val="accent1"/>
+          </a:effectRef>
+          <a:fontRef idx="minor">
+            <a:schemeClr val="lt1"/>
+          </a:fontRef>
+        </p:style>
+        <p:txBody>
+          <a:bodyPr wrap="square" lIns="73152" rIns="73152" rtlCol="0" anchor="ctr"/>
+          <a:lstStyle/>
+          <a:p>
+            <a:pPr algn="l"/>
+            <a:r>
+              <a:rPr sz="1100" b="1">
+                <a:solidFill>
+                  <a:srgbClr val="111111"/>
+                </a:solidFill>
+              </a:rPr>
+              <a:t>Backend clones repo, runs setup_command then start_command</a:t>
+            </a:r>
+          </a:p>
+        </p:txBody>
+      </p:sp>
+      <p:sp>
+        <p:nvSpPr>
+          <p:cNvPr id="11" name="Rounded Rectangle 10"/>
+          <p:cNvSpPr/>
+          <p:nvPr/>
+        </p:nvSpPr>
+        <p:spPr>
+          <a:xfrm>
+            <a:off x="6153912" y="2286000"/>
+            <a:ext cx="5669280" cy="2468880"/>
+          </a:xfrm>
+          <a:prstGeom prst="roundRect">
+            <a:avLst/>
+          </a:prstGeom>
+          <a:solidFill>
+            <a:srgbClr val="FAFAFA"/>
+          </a:solidFill>
+          <a:ln w="19050">
+            <a:solidFill>
+              <a:srgbClr val="0B2A4A"/>
+            </a:solidFill>
+          </a:ln>
+        </p:spPr>
+        <p:style>
+          <a:lnRef idx="1">
+            <a:schemeClr val="accent1"/>
+          </a:lnRef>
+          <a:fillRef idx="3">
+            <a:schemeClr val="accent1"/>
+          </a:fillRef>
+          <a:effectRef idx="2">
+            <a:schemeClr val="accent1"/>
+          </a:effectRef>
+          <a:fontRef idx="minor">
+            <a:schemeClr val="lt1"/>
+          </a:fontRef>
+        </p:style>
+        <p:txBody>
+          <a:bodyPr rtlCol="0" anchor="ctr"/>
+          <a:lstStyle/>
+          <a:p>
+            <a:endParaRPr/>
+          </a:p>
+        </p:txBody>
+      </p:sp>
+      <p:sp>
+        <p:nvSpPr>
+          <p:cNvPr id="12" name="Rectangle 11"/>
+          <p:cNvSpPr/>
+          <p:nvPr/>
+        </p:nvSpPr>
+        <p:spPr>
+          <a:xfrm>
+            <a:off x="6153912" y="2286000"/>
+            <a:ext cx="5669280" cy="365760"/>
+          </a:xfrm>
+          <a:prstGeom prst="rect">
+            <a:avLst/>
+          </a:prstGeom>
+          <a:solidFill>
+            <a:srgbClr val="0B2A4A"/>
+          </a:solidFill>
+          <a:ln>
+            <a:noFill/>
+          </a:ln>
+        </p:spPr>
+        <p:style>
+          <a:lnRef idx="1">
+            <a:schemeClr val="accent1"/>
+          </a:lnRef>
+          <a:fillRef idx="3">
+            <a:schemeClr val="accent1"/>
+          </a:fillRef>
+          <a:effectRef idx="2">
+            <a:schemeClr val="accent1"/>
+          </a:effectRef>
+          <a:fontRef idx="minor">
+            <a:schemeClr val="lt1"/>
+          </a:fontRef>
+        </p:style>
+        <p:txBody>
+          <a:bodyPr tIns="27432" bIns="27432" rtlCol="0" anchor="ctr"/>
+          <a:lstStyle/>
+          <a:p>
+            <a:pPr algn="l"/>
+            <a:r>
+              <a:rPr sz="1300" b="1">
+                <a:solidFill>
+                  <a:srgbClr val="FFFFFF"/>
+                </a:solidFill>
+              </a:rPr>
+              <a:t>Path B — Docker image → Bring-Your-Own-Image (BYOI)</a:t>
+            </a:r>
+          </a:p>
+        </p:txBody>
+      </p:sp>
+      <p:sp>
+        <p:nvSpPr>
+          <p:cNvPr id="13" name="Rectangle 12"/>
+          <p:cNvSpPr/>
+          <p:nvPr/>
+        </p:nvSpPr>
+        <p:spPr>
+          <a:xfrm>
+            <a:off x="6263640" y="2724912"/>
+            <a:ext cx="5449824" cy="615696"/>
+          </a:xfrm>
+          <a:prstGeom prst="rect">
+            <a:avLst/>
+          </a:prstGeom>
+          <a:solidFill>
+            <a:srgbClr val="F2F2F2"/>
+          </a:solidFill>
+          <a:ln w="6350">
+            <a:solidFill>
+              <a:srgbClr val="0B2A4A"/>
+            </a:solidFill>
+          </a:ln>
+        </p:spPr>
+        <p:style>
+          <a:lnRef idx="1">
+            <a:schemeClr val="accent1"/>
+          </a:lnRef>
+          <a:fillRef idx="3">
+            <a:schemeClr val="accent1"/>
+          </a:fillRef>
+          <a:effectRef idx="2">
+            <a:schemeClr val="accent1"/>
+          </a:effectRef>
+          <a:fontRef idx="minor">
+            <a:schemeClr val="lt1"/>
+          </a:fontRef>
+        </p:style>
+        <p:txBody>
+          <a:bodyPr wrap="square" lIns="73152" rIns="73152" rtlCol="0" anchor="ctr"/>
+          <a:lstStyle/>
+          <a:p>
+            <a:pPr algn="l"/>
+            <a:r>
+              <a:rPr sz="1100" b="1">
+                <a:solidFill>
+                  <a:srgbClr val="111111"/>
+                </a:solidFill>
+              </a:rPr>
+              <a:t>Claude Code writes Dockerfile — faithful conda-env reproduction</a:t>
+            </a:r>
+          </a:p>
+        </p:txBody>
+      </p:sp>
+      <p:sp>
+        <p:nvSpPr>
+          <p:cNvPr id="14" name="Rectangle 13"/>
+          <p:cNvSpPr/>
+          <p:nvPr/>
+        </p:nvSpPr>
+        <p:spPr>
+          <a:xfrm>
+            <a:off x="6263640" y="3395472"/>
+            <a:ext cx="5449824" cy="615696"/>
+          </a:xfrm>
+          <a:prstGeom prst="rect">
+            <a:avLst/>
+          </a:prstGeom>
+          <a:solidFill>
+            <a:srgbClr val="F2F2F2"/>
+          </a:solidFill>
+          <a:ln w="6350">
+            <a:solidFill>
+              <a:srgbClr val="0B2A4A"/>
+            </a:solidFill>
+          </a:ln>
+        </p:spPr>
+        <p:style>
+          <a:lnRef idx="1">
+            <a:schemeClr val="accent1"/>
+          </a:lnRef>
+          <a:fillRef idx="3">
+            <a:schemeClr val="accent1"/>
+          </a:fillRef>
+          <a:effectRef idx="2">
+            <a:schemeClr val="accent1"/>
+          </a:effectRef>
+          <a:fontRef idx="minor">
+            <a:schemeClr val="lt1"/>
+          </a:fontRef>
+        </p:style>
+        <p:txBody>
+          <a:bodyPr wrap="square" lIns="73152" rIns="73152" rtlCol="0" anchor="ctr"/>
+          <a:lstStyle/>
+          <a:p>
+            <a:pPr algn="l"/>
+            <a:r>
+              <a:rPr sz="1100" b="1">
+                <a:solidFill>
+                  <a:srgbClr val="111111"/>
+                </a:solidFill>
+              </a:rPr>
+              <a:t>Build + push to registry with content-addressed tag (not :latest)</a:t>
+            </a:r>
+          </a:p>
+        </p:txBody>
+      </p:sp>
+      <p:sp>
+        <p:nvSpPr>
+          <p:cNvPr id="15" name="Rectangle 14"/>
+          <p:cNvSpPr/>
+          <p:nvPr/>
+        </p:nvSpPr>
+        <p:spPr>
+          <a:xfrm>
+            <a:off x="6263640" y="4066032"/>
+            <a:ext cx="5449824" cy="615696"/>
+          </a:xfrm>
+          <a:prstGeom prst="rect">
+            <a:avLst/>
+          </a:prstGeom>
+          <a:solidFill>
+            <a:srgbClr val="F2F2F2"/>
+          </a:solidFill>
+          <a:ln w="6350">
+            <a:solidFill>
+              <a:srgbClr val="0B2A4A"/>
+            </a:solidFill>
+          </a:ln>
+        </p:spPr>
+        <p:style>
+          <a:lnRef idx="1">
+            <a:schemeClr val="accent1"/>
+          </a:lnRef>
+          <a:fillRef idx="3">
+            <a:schemeClr val="accent1"/>
+          </a:fillRef>
+          <a:effectRef idx="2">
+            <a:schemeClr val="accent1"/>
+          </a:effectRef>
+          <a:fontRef idx="minor">
+            <a:schemeClr val="lt1"/>
+          </a:fontRef>
+        </p:style>
+        <p:txBody>
+          <a:bodyPr wrap="square" lIns="73152" rIns="73152" rtlCol="0" anchor="ctr"/>
+          <a:lstStyle/>
+          <a:p>
+            <a:pPr algn="l"/>
+            <a:r>
+              <a:rPr sz="1100" b="1">
+                <a:solidFill>
+                  <a:srgbClr val="111111"/>
+                </a:solidFill>
+              </a:rPr>
+              <a:t>Claude Code authors a custom_code step (BYOI) — backend pulls the image</a:t>
+            </a:r>
+          </a:p>
+        </p:txBody>
+      </p:sp>
+      <p:sp>
+        <p:nvSpPr>
+          <p:cNvPr id="16" name="Down Arrow 15"/>
+          <p:cNvSpPr/>
+          <p:nvPr/>
+        </p:nvSpPr>
+        <p:spPr>
+          <a:xfrm>
+            <a:off x="3017520" y="4800600"/>
+            <a:ext cx="320040" cy="274320"/>
+          </a:xfrm>
+          <a:prstGeom prst="downArrow">
+            <a:avLst/>
+          </a:prstGeom>
+          <a:solidFill>
+            <a:srgbClr val="C93C20"/>
+          </a:solidFill>
+          <a:ln>
+            <a:noFill/>
+          </a:ln>
+        </p:spPr>
+        <p:style>
+          <a:lnRef idx="1">
+            <a:schemeClr val="accent1"/>
+          </a:lnRef>
+          <a:fillRef idx="3">
+            <a:schemeClr val="accent1"/>
+          </a:fillRef>
+          <a:effectRef idx="2">
+            <a:schemeClr val="accent1"/>
+          </a:effectRef>
+          <a:fontRef idx="minor">
+            <a:schemeClr val="lt1"/>
+          </a:fontRef>
+        </p:style>
+        <p:txBody>
+          <a:bodyPr rtlCol="0" anchor="ctr"/>
+          <a:lstStyle/>
+          <a:p>
+            <a:pPr algn="ctr"/>
+            <a:endParaRPr/>
+          </a:p>
+        </p:txBody>
+      </p:sp>
+      <p:sp>
+        <p:nvSpPr>
+          <p:cNvPr id="17" name="Down Arrow 16"/>
+          <p:cNvSpPr/>
+          <p:nvPr/>
+        </p:nvSpPr>
+        <p:spPr>
+          <a:xfrm>
+            <a:off x="8869680" y="4800600"/>
+            <a:ext cx="320040" cy="274320"/>
+          </a:xfrm>
+          <a:prstGeom prst="downArrow">
+            <a:avLst/>
+          </a:prstGeom>
+          <a:solidFill>
+            <a:srgbClr val="C93C20"/>
+          </a:solidFill>
+          <a:ln>
+            <a:noFill/>
+          </a:ln>
+        </p:spPr>
+        <p:style>
+          <a:lnRef idx="1">
+            <a:schemeClr val="accent1"/>
+          </a:lnRef>
+          <a:fillRef idx="3">
+            <a:schemeClr val="accent1"/>
+          </a:fillRef>
+          <a:effectRef idx="2">
+            <a:schemeClr val="accent1"/>
+          </a:effectRef>
+          <a:fontRef idx="minor">
+            <a:schemeClr val="lt1"/>
+          </a:fontRef>
+        </p:style>
+        <p:txBody>
+          <a:bodyPr rtlCol="0" anchor="ctr"/>
+          <a:lstStyle/>
+          <a:p>
+            <a:pPr algn="ctr"/>
+            <a:endParaRPr/>
+          </a:p>
+        </p:txBody>
+      </p:sp>
+      <p:sp>
+        <p:nvSpPr>
+          <p:cNvPr id="18" name="Rounded Rectangle 17"/>
+          <p:cNvSpPr/>
+          <p:nvPr/>
+        </p:nvSpPr>
+        <p:spPr>
+          <a:xfrm>
+            <a:off x="1280160" y="5166360"/>
+            <a:ext cx="9628632" cy="1051560"/>
+          </a:xfrm>
+          <a:prstGeom prst="roundRect">
+            <a:avLst/>
+          </a:prstGeom>
+          <a:solidFill>
+            <a:srgbClr val="FAFAFA"/>
+          </a:solidFill>
+          <a:ln w="19050">
+            <a:solidFill>
+              <a:srgbClr val="0B2A4A"/>
+            </a:solidFill>
+          </a:ln>
+        </p:spPr>
+        <p:style>
+          <a:lnRef idx="1">
+            <a:schemeClr val="accent1"/>
+          </a:lnRef>
+          <a:fillRef idx="3">
+            <a:schemeClr val="accent1"/>
+          </a:fillRef>
+          <a:effectRef idx="2">
+            <a:schemeClr val="accent1"/>
+          </a:effectRef>
+          <a:fontRef idx="minor">
+            <a:schemeClr val="lt1"/>
+          </a:fontRef>
+        </p:style>
+        <p:txBody>
+          <a:bodyPr rtlCol="0" anchor="ctr"/>
+          <a:lstStyle/>
+          <a:p>
+            <a:endParaRPr/>
+          </a:p>
+        </p:txBody>
+      </p:sp>
+      <p:sp>
+        <p:nvSpPr>
+          <p:cNvPr id="19" name="Rectangle 18"/>
+          <p:cNvSpPr/>
+          <p:nvPr/>
+        </p:nvSpPr>
+        <p:spPr>
+          <a:xfrm>
+            <a:off x="1280160" y="5166360"/>
+            <a:ext cx="9628632" cy="365760"/>
+          </a:xfrm>
+          <a:prstGeom prst="rect">
+            <a:avLst/>
+          </a:prstGeom>
+          <a:solidFill>
+            <a:srgbClr val="0B2A4A"/>
+          </a:solidFill>
+          <a:ln>
+            <a:noFill/>
+          </a:ln>
+        </p:spPr>
+        <p:style>
+          <a:lnRef idx="1">
+            <a:schemeClr val="accent1"/>
+          </a:lnRef>
+          <a:fillRef idx="3">
+            <a:schemeClr val="accent1"/>
+          </a:fillRef>
+          <a:effectRef idx="2">
+            <a:schemeClr val="accent1"/>
+          </a:effectRef>
+          <a:fontRef idx="minor">
+            <a:schemeClr val="lt1"/>
+          </a:fontRef>
+        </p:style>
+        <p:txBody>
+          <a:bodyPr tIns="27432" bIns="27432" rtlCol="0" anchor="ctr"/>
+          <a:lstStyle/>
+          <a:p>
+            <a:pPr algn="l"/>
+            <a:r>
+              <a:rPr sz="1300" b="1">
+                <a:solidFill>
+                  <a:srgbClr val="FFFFFF"/>
+                </a:solidFill>
+              </a:rPr>
+              <a:t>Claude Code constructs the build.yaml → submit_job (Granite.build)</a:t>
+            </a:r>
+          </a:p>
+        </p:txBody>
+      </p:sp>
+      <p:sp>
+        <p:nvSpPr>
+          <p:cNvPr id="20" name="Rectangle 19"/>
+          <p:cNvSpPr/>
+          <p:nvPr/>
+        </p:nvSpPr>
+        <p:spPr>
+          <a:xfrm>
+            <a:off x="1389888" y="5605272"/>
+            <a:ext cx="9409176" cy="242316"/>
+          </a:xfrm>
+          <a:prstGeom prst="rect">
+            <a:avLst/>
+          </a:prstGeom>
+          <a:solidFill>
+            <a:srgbClr val="F2F2F2"/>
+          </a:solidFill>
+          <a:ln w="6350">
+            <a:solidFill>
+              <a:srgbClr val="0B2A4A"/>
+            </a:solidFill>
+          </a:ln>
+        </p:spPr>
+        <p:style>
+          <a:lnRef idx="1">
+            <a:schemeClr val="accent1"/>
+          </a:lnRef>
+          <a:fillRef idx="3">
+            <a:schemeClr val="accent1"/>
+          </a:fillRef>
+          <a:effectRef idx="2">
+            <a:schemeClr val="accent1"/>
+          </a:effectRef>
+          <a:fontRef idx="minor">
+            <a:schemeClr val="lt1"/>
+          </a:fontRef>
+        </p:style>
+        <p:txBody>
+          <a:bodyPr wrap="square" lIns="73152" rIns="73152" rtlCol="0" anchor="ctr"/>
+          <a:lstStyle/>
+          <a:p>
+            <a:pPr algn="l"/>
+            <a:r>
+              <a:rPr sz="1100" b="1">
+                <a:solidFill>
+                  <a:srgbClr val="111111"/>
+                </a:solidFill>
+              </a:rPr>
+              <a:t>At-scale execution on backends (Docker · RunPod · SkyPilot · k8s · Slurm)</a:t>
+            </a:r>
+          </a:p>
+        </p:txBody>
+      </p:sp>
+      <p:sp>
+        <p:nvSpPr>
+          <p:cNvPr id="21" name="Rectangle 20"/>
+          <p:cNvSpPr/>
+          <p:nvPr/>
+        </p:nvSpPr>
+        <p:spPr>
+          <a:xfrm>
+            <a:off x="1389888" y="5902452"/>
+            <a:ext cx="9409176" cy="242316"/>
+          </a:xfrm>
+          <a:prstGeom prst="rect">
+            <a:avLst/>
+          </a:prstGeom>
+          <a:solidFill>
+            <a:srgbClr val="F2F2F2"/>
+          </a:solidFill>
+          <a:ln w="6350">
+            <a:solidFill>
+              <a:srgbClr val="0B2A4A"/>
+            </a:solidFill>
+          </a:ln>
+        </p:spPr>
+        <p:style>
+          <a:lnRef idx="1">
+            <a:schemeClr val="accent1"/>
+          </a:lnRef>
+          <a:fillRef idx="3">
+            <a:schemeClr val="accent1"/>
+          </a:fillRef>
+          <a:effectRef idx="2">
+            <a:schemeClr val="accent1"/>
+          </a:effectRef>
+          <a:fontRef idx="minor">
+            <a:schemeClr val="lt1"/>
+          </a:fontRef>
+        </p:style>
+        <p:txBody>
+          <a:bodyPr wrap="square" lIns="73152" rIns="73152" rtlCol="0" anchor="ctr"/>
+          <a:lstStyle/>
+          <a:p>
+            <a:pPr algn="l"/>
+            <a:r>
+              <a:rPr sz="1100" b="1">
+                <a:solidFill>
+                  <a:srgbClr val="111111"/>
+                </a:solidFill>
+              </a:rPr>
+              <a:t>Artifacts registered automatically with lineage + provenance</a:t>
+            </a:r>
+          </a:p>
+        </p:txBody>
+      </p:sp>
+      <p:sp>
+        <p:nvSpPr>
+          <p:cNvPr id="22" name="Rectangle 21"/>
+          <p:cNvSpPr/>
+          <p:nvPr/>
+        </p:nvSpPr>
+        <p:spPr>
+          <a:xfrm>
+            <a:off x="0" y="6309360"/>
+            <a:ext cx="12188952" cy="548640"/>
+          </a:xfrm>
+          <a:prstGeom prst="rect">
+            <a:avLst/>
+          </a:prstGeom>
+          <a:solidFill>
+            <a:srgbClr val="0B2A4A"/>
+          </a:solidFill>
+          <a:ln>
+            <a:noFill/>
+          </a:ln>
+        </p:spPr>
+        <p:style>
+          <a:lnRef idx="1">
+            <a:schemeClr val="accent1"/>
+          </a:lnRef>
+          <a:fillRef idx="3">
+            <a:schemeClr val="accent1"/>
+          </a:fillRef>
+          <a:effectRef idx="2">
+            <a:schemeClr val="accent1"/>
+          </a:effectRef>
+          <a:fontRef idx="minor">
+            <a:schemeClr val="lt1"/>
+          </a:fontRef>
+        </p:style>
+        <p:txBody>
+          <a:bodyPr lIns="274320" rIns="274320" rtlCol="0" anchor="ctr"/>
+          <a:lstStyle/>
+          <a:p>
+            <a:pPr algn="l"/>
+            <a:r>
               <a:rPr sz="1400" b="1">
                 <a:solidFill>
                   <a:srgbClr val="FFFFFF"/>
                 </a:solidFill>
               </a:rPr>
-              <a:t>Conversations end. Flight plans and logbooks remain — and can be searched, shared, and resumed.</a:t>
+              <a:t>Two paths, one control plane — Claude Code assists from the first commit to the last artifact.</a:t>
             </a:r>
           </a:p>
         </p:txBody>

</xml_diff>

<commit_message>
docs(presentations): update Granite.build pitch deck
Co-Authored-By: Claude Opus 4.7 (1M context) <noreply@anthropic.com>
</commit_message>
<xml_diff>
--- a/docs/presentations/2026-04-28-openmythos-on-BlueVela.pptx
+++ b/docs/presentations/2026-04-28-openmythos-on-BlueVela.pptx
@@ -8,6 +8,7 @@
     <p:sldId id="256" r:id="rId2"/>
     <p:sldId id="257" r:id="rId3"/>
     <p:sldId id="258" r:id="rId4"/>
+    <p:sldId id="259" r:id="rId5"/>
   </p:sldIdLst>
   <p:sldSz cx="12188825" cy="6858000"/>
   <p:notesSz cx="6858000" cy="9144000"/>
@@ -3758,20 +3759,12 @@
           </a:p>
           <a:p>
             <a:r>
-              <a:rPr sz="1200">
-                <a:solidFill>
-                  <a:srgbClr val="111111"/>
-                </a:solidFill>
-              </a:rPr>
-              <a:t>• NCCL </a:t>
-            </a:r>
-            <a:r>
               <a:rPr sz="1200" dirty="0">
                 <a:solidFill>
                   <a:srgbClr val="111111"/>
                 </a:solidFill>
               </a:rPr>
-              <a:t>timeout, ACT deadlock, </a:t>
+              <a:t>• NCCL timeout, ACT deadlock, </a:t>
             </a:r>
             <a:r>
               <a:rPr sz="1200" dirty="0" err="1">
@@ -4198,12 +4191,28 @@
           <a:p>
             <a:pPr algn="l"/>
             <a:r>
-              <a:rPr sz="1300" b="1">
+              <a:rPr sz="1300" b="1" dirty="0">
                 <a:solidFill>
                   <a:srgbClr val="FFFFFF"/>
                 </a:solidFill>
               </a:rPr>
-              <a:t>Sandbox (OpenShell · k8s-sig)</a:t>
+              <a:t>Sandbox (</a:t>
+            </a:r>
+            <a:r>
+              <a:rPr sz="1300" b="1" dirty="0" err="1">
+                <a:solidFill>
+                  <a:srgbClr val="FFFFFF"/>
+                </a:solidFill>
+              </a:rPr>
+              <a:t>OpenShell</a:t>
+            </a:r>
+            <a:r>
+              <a:rPr sz="1300" b="1" dirty="0">
+                <a:solidFill>
+                  <a:srgbClr val="FFFFFF"/>
+                </a:solidFill>
+              </a:rPr>
+              <a:t> · k8s-sig)</a:t>
             </a:r>
           </a:p>
         </p:txBody>
@@ -5090,7 +5099,7 @@
           <a:lstStyle/>
           <a:p>
             <a:r>
-              <a:rPr sz="1600" b="1">
+              <a:rPr sz="1600" b="1" dirty="0">
                 <a:solidFill>
                   <a:srgbClr val="0B2A4A"/>
                 </a:solidFill>
@@ -5100,7 +5109,7 @@
           </a:p>
           <a:p>
             <a:r>
-              <a:rPr sz="1200">
+              <a:rPr sz="1200" dirty="0">
                 <a:solidFill>
                   <a:srgbClr val="111111"/>
                 </a:solidFill>
@@ -5110,7 +5119,7 @@
           </a:p>
           <a:p>
             <a:r>
-              <a:rPr sz="1200">
+              <a:rPr sz="1200" dirty="0">
                 <a:solidFill>
                   <a:srgbClr val="111111"/>
                 </a:solidFill>
@@ -5120,7 +5129,7 @@
           </a:p>
           <a:p>
             <a:r>
-              <a:rPr sz="1200">
+              <a:rPr sz="1200" dirty="0">
                 <a:solidFill>
                   <a:srgbClr val="111111"/>
                 </a:solidFill>
@@ -5537,7 +5546,7 @@
           <a:p>
             <a:pPr algn="l"/>
             <a:r>
-              <a:rPr sz="1300" b="1">
+              <a:rPr sz="1300" b="1" dirty="0">
                 <a:solidFill>
                   <a:srgbClr val="FFFFFF"/>
                 </a:solidFill>
@@ -5588,15 +5597,43 @@
           <a:bodyPr wrap="square" lIns="73152" rIns="73152" rtlCol="0" anchor="ctr"/>
           <a:lstStyle/>
           <a:p>
-            <a:pPr algn="l"/>
-            <a:r>
-              <a:rPr sz="1100" b="1">
+            <a:r>
+              <a:rPr sz="1100" b="1" dirty="0">
                 <a:solidFill>
                   <a:srgbClr val="111111"/>
                 </a:solidFill>
               </a:rPr>
               <a:t>Commit &amp; push to GitHub (pin commit SHA, not a branch ref)</a:t>
             </a:r>
+            <a:r>
+              <a:rPr lang="en-US" sz="1100" b="1" dirty="0">
+                <a:solidFill>
+                  <a:srgbClr val="111111"/>
+                </a:solidFill>
+              </a:rPr>
+              <a:t>, capture faithful </a:t>
+            </a:r>
+            <a:r>
+              <a:rPr lang="en-US" sz="1100" b="1" dirty="0" err="1">
+                <a:solidFill>
+                  <a:srgbClr val="111111"/>
+                </a:solidFill>
+              </a:rPr>
+              <a:t>conda</a:t>
+            </a:r>
+            <a:r>
+              <a:rPr lang="en-US" sz="1100" b="1" dirty="0">
+                <a:solidFill>
+                  <a:srgbClr val="111111"/>
+                </a:solidFill>
+              </a:rPr>
+              <a:t>-env </a:t>
+            </a:r>
+            <a:endParaRPr sz="1100" b="1" dirty="0">
+              <a:solidFill>
+                <a:srgbClr val="111111"/>
+              </a:solidFill>
+            </a:endParaRPr>
           </a:p>
         </p:txBody>
       </p:sp>
@@ -5694,15 +5731,75 @@
           <a:bodyPr wrap="square" lIns="73152" rIns="73152" rtlCol="0" anchor="ctr"/>
           <a:lstStyle/>
           <a:p>
-            <a:pPr algn="l"/>
-            <a:r>
-              <a:rPr sz="1100" b="1">
-                <a:solidFill>
-                  <a:srgbClr val="111111"/>
-                </a:solidFill>
-              </a:rPr>
-              <a:t>Backend clones repo, runs setup_command then start_command</a:t>
-            </a:r>
+            <a:r>
+              <a:rPr sz="1100" b="1" dirty="0">
+                <a:solidFill>
+                  <a:srgbClr val="111111"/>
+                </a:solidFill>
+              </a:rPr>
+              <a:t>Backend clones repo,</a:t>
+            </a:r>
+            <a:r>
+              <a:rPr lang="en-US" sz="1100" b="1" dirty="0">
+                <a:solidFill>
+                  <a:srgbClr val="111111"/>
+                </a:solidFill>
+              </a:rPr>
+              <a:t> </a:t>
+            </a:r>
+            <a:r>
+              <a:rPr sz="1100" b="1" dirty="0">
+                <a:solidFill>
+                  <a:srgbClr val="111111"/>
+                </a:solidFill>
+              </a:rPr>
+              <a:t>runs </a:t>
+            </a:r>
+            <a:r>
+              <a:rPr sz="1100" b="1" dirty="0" err="1">
+                <a:solidFill>
+                  <a:srgbClr val="111111"/>
+                </a:solidFill>
+              </a:rPr>
+              <a:t>setup_command</a:t>
+            </a:r>
+            <a:r>
+              <a:rPr sz="1100" b="1" dirty="0">
+                <a:solidFill>
+                  <a:srgbClr val="111111"/>
+                </a:solidFill>
+              </a:rPr>
+              <a:t> </a:t>
+            </a:r>
+            <a:r>
+              <a:rPr lang="en-US" sz="1100" b="1" dirty="0">
+                <a:solidFill>
+                  <a:srgbClr val="111111"/>
+                </a:solidFill>
+              </a:rPr>
+              <a:t>(reproduces Conda environment ) </a:t>
+            </a:r>
+            <a:r>
+              <a:rPr sz="1100" b="1" dirty="0">
+                <a:solidFill>
+                  <a:srgbClr val="111111"/>
+                </a:solidFill>
+              </a:rPr>
+              <a:t>then </a:t>
+            </a:r>
+            <a:r>
+              <a:rPr sz="1100" b="1" dirty="0" err="1">
+                <a:solidFill>
+                  <a:srgbClr val="111111"/>
+                </a:solidFill>
+              </a:rPr>
+              <a:t>start_command</a:t>
+            </a:r>
+            <a:endParaRPr sz="1100" b="1" dirty="0">
+              <a:solidFill>
+                <a:srgbClr val="111111"/>
+              </a:solidFill>
+            </a:endParaRPr>
           </a:p>
         </p:txBody>
       </p:sp>
@@ -5845,12 +5942,44 @@
           <a:p>
             <a:pPr algn="l"/>
             <a:r>
-              <a:rPr sz="1100" b="1">
-                <a:solidFill>
-                  <a:srgbClr val="111111"/>
-                </a:solidFill>
-              </a:rPr>
-              <a:t>Claude Code writes Dockerfile — faithful conda-env reproduction</a:t>
+              <a:rPr sz="1100" b="1" dirty="0">
+                <a:solidFill>
+                  <a:srgbClr val="111111"/>
+                </a:solidFill>
+              </a:rPr>
+              <a:t>Claude Code writes </a:t>
+            </a:r>
+            <a:r>
+              <a:rPr sz="1100" b="1" dirty="0" err="1">
+                <a:solidFill>
+                  <a:srgbClr val="111111"/>
+                </a:solidFill>
+              </a:rPr>
+              <a:t>Dockerfile</a:t>
+            </a:r>
+            <a:r>
+              <a:rPr sz="1100" b="1" dirty="0">
+                <a:solidFill>
+                  <a:srgbClr val="111111"/>
+                </a:solidFill>
+              </a:rPr>
+              <a:t> — faithful </a:t>
+            </a:r>
+            <a:r>
+              <a:rPr sz="1100" b="1" dirty="0" err="1">
+                <a:solidFill>
+                  <a:srgbClr val="111111"/>
+                </a:solidFill>
+              </a:rPr>
+              <a:t>conda</a:t>
+            </a:r>
+            <a:r>
+              <a:rPr sz="1100" b="1" dirty="0">
+                <a:solidFill>
+                  <a:srgbClr val="111111"/>
+                </a:solidFill>
+              </a:rPr>
+              <a:t>-env reproduction</a:t>
             </a:r>
           </a:p>
         </p:txBody>
@@ -6135,12 +6264,60 @@
           <a:p>
             <a:pPr algn="l"/>
             <a:r>
-              <a:rPr sz="1300" b="1">
+              <a:rPr sz="1300" b="1" dirty="0">
                 <a:solidFill>
                   <a:srgbClr val="FFFFFF"/>
                 </a:solidFill>
               </a:rPr>
-              <a:t>Claude Code constructs the build.yaml → submit_job (Granite.build)</a:t>
+              <a:t>Claude Code constructs the </a:t>
+            </a:r>
+            <a:r>
+              <a:rPr sz="1300" b="1" dirty="0" err="1">
+                <a:solidFill>
+                  <a:srgbClr val="FFFFFF"/>
+                </a:solidFill>
+              </a:rPr>
+              <a:t>build.yaml</a:t>
+            </a:r>
+            <a:r>
+              <a:rPr sz="1300" b="1" dirty="0">
+                <a:solidFill>
+                  <a:srgbClr val="FFFFFF"/>
+                </a:solidFill>
+              </a:rPr>
+              <a:t> → </a:t>
+            </a:r>
+            <a:r>
+              <a:rPr sz="1300" b="1" dirty="0" err="1">
+                <a:solidFill>
+                  <a:srgbClr val="FFFFFF"/>
+                </a:solidFill>
+              </a:rPr>
+              <a:t>submit_job</a:t>
+            </a:r>
+            <a:r>
+              <a:rPr sz="1300" b="1" dirty="0">
+                <a:solidFill>
+                  <a:srgbClr val="FFFFFF"/>
+                </a:solidFill>
+              </a:rPr>
+              <a:t> (</a:t>
+            </a:r>
+            <a:r>
+              <a:rPr sz="1300" b="1" dirty="0" err="1">
+                <a:solidFill>
+                  <a:srgbClr val="FFFFFF"/>
+                </a:solidFill>
+              </a:rPr>
+              <a:t>Granite.build</a:t>
+            </a:r>
+            <a:r>
+              <a:rPr sz="1300" b="1" dirty="0">
+                <a:solidFill>
+                  <a:srgbClr val="FFFFFF"/>
+                </a:solidFill>
+              </a:rPr>
+              <a:t>)</a:t>
             </a:r>
           </a:p>
         </p:txBody>
@@ -6298,6 +6475,301 @@
                 </a:solidFill>
               </a:rPr>
               <a:t>Two paths, one control plane — Claude Code assists from the first commit to the last artifact.</a:t>
+            </a:r>
+          </a:p>
+        </p:txBody>
+      </p:sp>
+    </p:spTree>
+  </p:cSld>
+  <p:clrMapOvr>
+    <a:masterClrMapping/>
+  </p:clrMapOvr>
+</p:sld>
+</file>
+
+<file path=ppt/slides/slide4.xml><?xml version="1.0" encoding="utf-8"?>
+<p:sld xmlns:a="http://schemas.openxmlformats.org/drawingml/2006/main" xmlns:r="http://schemas.openxmlformats.org/officeDocument/2006/relationships" xmlns:p="http://schemas.openxmlformats.org/presentationml/2006/main">
+  <p:cSld>
+    <p:spTree>
+      <p:nvGrpSpPr>
+        <p:cNvPr id="1" name=""/>
+        <p:cNvGrpSpPr/>
+        <p:nvPr/>
+      </p:nvGrpSpPr>
+      <p:grpSpPr>
+        <a:xfrm>
+          <a:off x="0" y="0"/>
+          <a:ext cx="0" cy="0"/>
+          <a:chOff x="0" y="0"/>
+          <a:chExt cx="0" cy="0"/>
+        </a:xfrm>
+      </p:grpSpPr>
+      <p:sp>
+        <p:nvSpPr>
+          <p:cNvPr id="2" name="TextBox 1"/>
+          <p:cNvSpPr txBox="1"/>
+          <p:nvPr/>
+        </p:nvSpPr>
+        <p:spPr>
+          <a:xfrm>
+            <a:off x="457200" y="274320"/>
+            <a:ext cx="11247120" cy="914400"/>
+          </a:xfrm>
+          <a:prstGeom prst="rect">
+            <a:avLst/>
+          </a:prstGeom>
+          <a:noFill/>
+        </p:spPr>
+        <p:txBody>
+          <a:bodyPr wrap="square">
+            <a:spAutoFit/>
+          </a:bodyPr>
+          <a:lstStyle/>
+          <a:p>
+            <a:r>
+              <a:rPr sz="3000" b="1">
+                <a:solidFill>
+                  <a:srgbClr val="0B2A4A"/>
+                </a:solidFill>
+              </a:rPr>
+              <a:t>Flight plans + logbooks — external memory for experiments</a:t>
+            </a:r>
+          </a:p>
+          <a:p>
+            <a:r>
+              <a:rPr sz="1400" i="1">
+                <a:solidFill>
+                  <a:srgbClr val="555555"/>
+                </a:solidFill>
+              </a:rPr>
+              <a:t>The intent, the methodology, and the daily record — all durable and searchable</a:t>
+            </a:r>
+          </a:p>
+        </p:txBody>
+      </p:sp>
+      <p:sp>
+        <p:nvSpPr>
+          <p:cNvPr id="3" name="TextBox 2"/>
+          <p:cNvSpPr txBox="1"/>
+          <p:nvPr/>
+        </p:nvSpPr>
+        <p:spPr>
+          <a:xfrm>
+            <a:off x="457200" y="1325880"/>
+            <a:ext cx="5669280" cy="4754880"/>
+          </a:xfrm>
+          <a:prstGeom prst="rect">
+            <a:avLst/>
+          </a:prstGeom>
+          <a:noFill/>
+        </p:spPr>
+        <p:txBody>
+          <a:bodyPr wrap="square">
+            <a:spAutoFit/>
+          </a:bodyPr>
+          <a:lstStyle/>
+          <a:p>
+            <a:r>
+              <a:rPr sz="1600" b="1">
+                <a:solidFill>
+                  <a:srgbClr val="0B2A4A"/>
+                </a:solidFill>
+              </a:rPr>
+              <a:t>Flight plans: durable intent</a:t>
+            </a:r>
+          </a:p>
+          <a:p>
+            <a:r>
+              <a:rPr sz="1300">
+                <a:solidFill>
+                  <a:srgbClr val="111111"/>
+                </a:solidFill>
+              </a:rPr>
+              <a:t>• Co-authored with the agent in the sandbox; captures the what and the why</a:t>
+            </a:r>
+          </a:p>
+          <a:p>
+            <a:r>
+              <a:rPr sz="1300">
+                <a:solidFill>
+                  <a:srgbClr val="111111"/>
+                </a:solidFill>
+              </a:rPr>
+              <a:t>• Level 1 — Intent (human narrative)</a:t>
+            </a:r>
+          </a:p>
+          <a:p>
+            <a:r>
+              <a:rPr sz="1300">
+                <a:solidFill>
+                  <a:srgbClr val="111111"/>
+                </a:solidFill>
+              </a:rPr>
+              <a:t>• Level 2 — Methodology (structured steps, dependencies)</a:t>
+            </a:r>
+          </a:p>
+          <a:p>
+            <a:r>
+              <a:rPr sz="1300">
+                <a:solidFill>
+                  <a:srgbClr val="111111"/>
+                </a:solidFill>
+              </a:rPr>
+              <a:t>• Level 3 — Execution (build.yaml, derived at submit time)</a:t>
+            </a:r>
+          </a:p>
+          <a:p>
+            <a:r>
+              <a:rPr sz="1300">
+                <a:solidFill>
+                  <a:srgbClr val="111111"/>
+                </a:solidFill>
+              </a:rPr>
+              <a:t>• Append-only revision history; one plan spawns many builds as you iterate</a:t>
+            </a:r>
+          </a:p>
+          <a:p>
+            <a:r>
+              <a:rPr sz="1300">
+                <a:solidFill>
+                  <a:srgbClr val="111111"/>
+                </a:solidFill>
+              </a:rPr>
+              <a:t>• Every job carries plan_id → build → artifact — provenance by construction</a:t>
+            </a:r>
+          </a:p>
+        </p:txBody>
+      </p:sp>
+      <p:sp>
+        <p:nvSpPr>
+          <p:cNvPr id="4" name="TextBox 3"/>
+          <p:cNvSpPr txBox="1"/>
+          <p:nvPr/>
+        </p:nvSpPr>
+        <p:spPr>
+          <a:xfrm>
+            <a:off x="6355080" y="1325880"/>
+            <a:ext cx="5486400" cy="4754880"/>
+          </a:xfrm>
+          <a:prstGeom prst="rect">
+            <a:avLst/>
+          </a:prstGeom>
+          <a:noFill/>
+        </p:spPr>
+        <p:txBody>
+          <a:bodyPr wrap="square">
+            <a:spAutoFit/>
+          </a:bodyPr>
+          <a:lstStyle/>
+          <a:p>
+            <a:r>
+              <a:rPr sz="1600" b="1">
+                <a:solidFill>
+                  <a:srgbClr val="0B2A4A"/>
+                </a:solidFill>
+              </a:rPr>
+              <a:t>Logbooks: durable history</a:t>
+            </a:r>
+          </a:p>
+          <a:p>
+            <a:r>
+              <a:rPr sz="1300">
+                <a:solidFill>
+                  <a:srgbClr val="111111"/>
+                </a:solidFill>
+              </a:rPr>
+              <a:t>• Daily record of what was achieved, decided, or ruled out — not raw transcripts</a:t>
+            </a:r>
+          </a:p>
+          <a:p>
+            <a:r>
+              <a:rPr sz="1300">
+                <a:solidFill>
+                  <a:srgbClr val="111111"/>
+                </a:solidFill>
+              </a:rPr>
+              <a:t>• Searchable, shareable, persistent external record of agent sessions</a:t>
+            </a:r>
+          </a:p>
+          <a:p>
+            <a:r>
+              <a:rPr sz="1300">
+                <a:solidFill>
+                  <a:srgbClr val="111111"/>
+                </a:solidFill>
+              </a:rPr>
+              <a:t>• Future retrieval: answer months later why micro_batch=1 or why MLA over GQA</a:t>
+            </a:r>
+          </a:p>
+          <a:p>
+            <a:r>
+              <a:rPr sz="1300">
+                <a:solidFill>
+                  <a:srgbClr val="111111"/>
+                </a:solidFill>
+              </a:rPr>
+              <a:t>• Example: the 475-SSH audit was reconstructed from session transcripts — logbooks make this first-class</a:t>
+            </a:r>
+          </a:p>
+          <a:p>
+            <a:r>
+              <a:rPr sz="1300">
+                <a:solidFill>
+                  <a:srgbClr val="111111"/>
+                </a:solidFill>
+              </a:rPr>
+              <a:t>• Pairs with flight plans: the plan says what we meant to do, the logbook says what actually happened</a:t>
+            </a:r>
+          </a:p>
+        </p:txBody>
+      </p:sp>
+      <p:sp>
+        <p:nvSpPr>
+          <p:cNvPr id="5" name="Rectangle 4"/>
+          <p:cNvSpPr/>
+          <p:nvPr/>
+        </p:nvSpPr>
+        <p:spPr>
+          <a:xfrm>
+            <a:off x="0" y="6309360"/>
+            <a:ext cx="12188952" cy="548640"/>
+          </a:xfrm>
+          <a:prstGeom prst="rect">
+            <a:avLst/>
+          </a:prstGeom>
+          <a:solidFill>
+            <a:srgbClr val="0B2A4A"/>
+          </a:solidFill>
+          <a:ln>
+            <a:noFill/>
+          </a:ln>
+        </p:spPr>
+        <p:style>
+          <a:lnRef idx="1">
+            <a:schemeClr val="accent1"/>
+          </a:lnRef>
+          <a:fillRef idx="3">
+            <a:schemeClr val="accent1"/>
+          </a:fillRef>
+          <a:effectRef idx="2">
+            <a:schemeClr val="accent1"/>
+          </a:effectRef>
+          <a:fontRef idx="minor">
+            <a:schemeClr val="lt1"/>
+          </a:fontRef>
+        </p:style>
+        <p:txBody>
+          <a:bodyPr lIns="274320" rIns="274320" rtlCol="0" anchor="ctr"/>
+          <a:lstStyle/>
+          <a:p>
+            <a:pPr algn="l"/>
+            <a:r>
+              <a:rPr sz="1400" b="1">
+                <a:solidFill>
+                  <a:srgbClr val="FFFFFF"/>
+                </a:solidFill>
+              </a:rPr>
+              <a:t>Conversations end. Flight plans and logbooks remain — and can be searched, shared, and resumed.</a:t>
             </a:r>
           </a:p>
         </p:txBody>

</xml_diff>